<commit_message>
Add brand selection rationale and brand research to plan and deck
</commit_message>
<xml_diff>
--- a/slides/AI_MCN_Final_Presentation_EN.pptx
+++ b/slides/AI_MCN_Final_Presentation_EN.pptx
@@ -21,6 +21,7 @@
     <p:sldId id="269" r:id="rId20"/>
     <p:sldId id="270" r:id="rId21"/>
     <p:sldId id="271" r:id="rId22"/>
+    <p:sldId id="272" r:id="rId23"/>
   </p:sldIdLst>
   <p:sldSz cx="12191695" cy="6858000" type="screen4x3"/>
   <p:notesSz cx="6858000" cy="9144000"/>
@@ -3374,7 +3375,7 @@
               </a:defRPr>
             </a:pPr>
             <a:r>
-              <a:t>Network Diversity Diagnostics</a:t>
+              <a:t>Guardrails Against Bad Recommendations</a:t>
             </a:r>
           </a:p>
         </p:txBody>
@@ -3424,7 +3425,7 @@
       </p:sp>
       <p:pic>
         <p:nvPicPr>
-          <p:cNvPr id="4" name="Picture 3" descr="community_distribution_clean.png"/>
+          <p:cNvPr id="4" name="Picture 3" descr="evidence_vs_finalscore_top10.png"/>
           <p:cNvPicPr>
             <a:picLocks noChangeAspect="1"/>
           </p:cNvPicPr>
@@ -3439,7 +3440,7 @@
         <p:spPr>
           <a:xfrm>
             <a:off x="685800" y="1828800"/>
-            <a:ext cx="8686800" cy="4389120"/>
+            <a:ext cx="6993402" cy="4434840"/>
           </a:xfrm>
           <a:prstGeom prst="rect">
             <a:avLst/>
@@ -3454,8 +3455,8 @@
         </p:nvSpPr>
         <p:spPr>
           <a:xfrm>
-            <a:off x="7315200" y="1828800"/>
-            <a:ext cx="4114800" cy="4389120"/>
+            <a:off x="7342631" y="1828800"/>
+            <a:ext cx="4069080" cy="4434840"/>
           </a:xfrm>
           <a:prstGeom prst="roundRect">
             <a:avLst/>
@@ -3499,8 +3500,8 @@
         </p:nvSpPr>
         <p:spPr>
           <a:xfrm>
-            <a:off x="7516368" y="1938528"/>
-            <a:ext cx="3794760" cy="365760"/>
+            <a:off x="7543800" y="1938528"/>
+            <a:ext cx="3749040" cy="365760"/>
           </a:xfrm>
           <a:prstGeom prst="rect">
             <a:avLst/>
@@ -3522,7 +3523,7 @@
               </a:defRPr>
             </a:pPr>
             <a:r>
-              <a:t>Community results</a:t>
+              <a:t>Bias and quality controls</a:t>
             </a:r>
           </a:p>
         </p:txBody>
@@ -3535,8 +3536,8 @@
         </p:nvSpPr>
         <p:spPr>
           <a:xfrm>
-            <a:off x="7498079" y="2304288"/>
-            <a:ext cx="3794760" cy="3822191"/>
+            <a:off x="7525511" y="2304288"/>
+            <a:ext cx="3749040" cy="3867911"/>
           </a:xfrm>
           <a:prstGeom prst="rect">
             <a:avLst/>
@@ -3561,7 +3562,7 @@
               </a:defRPr>
             </a:pPr>
             <a:r>
-              <a:t>Non-micro communities discovered: 6</a:t>
+              <a:t>Low-evidence channels are automatically down-weighted.</a:t>
             </a:r>
           </a:p>
           <a:p>
@@ -3577,7 +3578,7 @@
               </a:defRPr>
             </a:pPr>
             <a:r>
-              <a:t>Largest non-micro community share: 43.8%</a:t>
+              <a:t>Diversity guardrail prevents single-cluster over-concentration.</a:t>
             </a:r>
           </a:p>
           <a:p>
@@ -3593,7 +3594,7 @@
               </a:defRPr>
             </a:pPr>
             <a:r>
-              <a:t>Micro/isolated channels separated to improve readability</a:t>
+              <a:t>Degree-only vs hybrid overlap: 2/10</a:t>
             </a:r>
           </a:p>
         </p:txBody>
@@ -3629,7 +3630,7 @@
               </a:defRPr>
             </a:pPr>
             <a:r>
-              <a:t>Community-aware matching for healthier shortlist diversity</a:t>
+              <a:t>Reduced popularity bias with evidence-based filtering</a:t>
             </a:r>
           </a:p>
         </p:txBody>
@@ -3683,7 +3684,7 @@
               </a:defRPr>
             </a:pPr>
             <a:r>
-              <a:t>ROI Scenario (Business Lens)</a:t>
+              <a:t>Network Diversity Diagnostics</a:t>
             </a:r>
           </a:p>
         </p:txBody>
@@ -3733,7 +3734,7 @@
       </p:sp>
       <p:pic>
         <p:nvPicPr>
-          <p:cNvPr id="4" name="Picture 3" descr="roi_funnel_base.png"/>
+          <p:cNvPr id="4" name="Picture 3" descr="community_distribution_clean.png"/>
           <p:cNvPicPr>
             <a:picLocks noChangeAspect="1"/>
           </p:cNvPicPr>
@@ -3748,7 +3749,7 @@
         <p:spPr>
           <a:xfrm>
             <a:off x="685800" y="1828800"/>
-            <a:ext cx="8046720" cy="4480560"/>
+            <a:ext cx="8686800" cy="4389120"/>
           </a:xfrm>
           <a:prstGeom prst="rect">
             <a:avLst/>
@@ -3763,8 +3764,8 @@
         </p:nvSpPr>
         <p:spPr>
           <a:xfrm>
-            <a:off x="7178040" y="1828800"/>
-            <a:ext cx="4251960" cy="4480560"/>
+            <a:off x="7315200" y="1828800"/>
+            <a:ext cx="4114800" cy="4389120"/>
           </a:xfrm>
           <a:prstGeom prst="roundRect">
             <a:avLst/>
@@ -3808,8 +3809,8 @@
         </p:nvSpPr>
         <p:spPr>
           <a:xfrm>
-            <a:off x="7379208" y="1938528"/>
-            <a:ext cx="3931920" cy="365760"/>
+            <a:off x="7516368" y="1938528"/>
+            <a:ext cx="3794760" cy="365760"/>
           </a:xfrm>
           <a:prstGeom prst="rect">
             <a:avLst/>
@@ -3831,7 +3832,7 @@
               </a:defRPr>
             </a:pPr>
             <a:r>
-              <a:t>Base scenario outputs</a:t>
+              <a:t>Community results</a:t>
             </a:r>
           </a:p>
         </p:txBody>
@@ -3844,8 +3845,8 @@
         </p:nvSpPr>
         <p:spPr>
           <a:xfrm>
-            <a:off x="7360919" y="2304288"/>
-            <a:ext cx="3931920" cy="3913632"/>
+            <a:off x="7498079" y="2304288"/>
+            <a:ext cx="3794760" cy="3822191"/>
           </a:xfrm>
           <a:prstGeom prst="rect">
             <a:avLst/>
@@ -3870,7 +3871,7 @@
               </a:defRPr>
             </a:pPr>
             <a:r>
-              <a:t>Budget: $50,000</a:t>
+              <a:t>Non-micro communities discovered: 6</a:t>
             </a:r>
           </a:p>
           <a:p>
@@ -3886,7 +3887,7 @@
               </a:defRPr>
             </a:pPr>
             <a:r>
-              <a:t>Impressions: 2,777,777</a:t>
+              <a:t>Largest non-micro community share: 43.8%</a:t>
             </a:r>
           </a:p>
           <a:p>
@@ -3902,39 +3903,7 @@
               </a:defRPr>
             </a:pPr>
             <a:r>
-              <a:t>Clicks: 49,999</a:t>
-            </a:r>
-          </a:p>
-          <a:p>
-            <a:pPr>
-              <a:spcAft>
-                <a:spcPts val="900"/>
-              </a:spcAft>
-              <a:defRPr sz="1600">
-                <a:solidFill>
-                  <a:srgbClr val="1C2D46"/>
-                </a:solidFill>
-                <a:latin typeface="Aptos"/>
-              </a:defRPr>
-            </a:pPr>
-            <a:r>
-              <a:t>Conversions: 1,499</a:t>
-            </a:r>
-          </a:p>
-          <a:p>
-            <a:pPr>
-              <a:spcAft>
-                <a:spcPts val="900"/>
-              </a:spcAft>
-              <a:defRPr sz="1600">
-                <a:solidFill>
-                  <a:srgbClr val="1C2D46"/>
-                </a:solidFill>
-                <a:latin typeface="Aptos"/>
-              </a:defRPr>
-            </a:pPr>
-            <a:r>
-              <a:t>Expected ROAS: 1.14x</a:t>
+              <a:t>Micro/isolated channels separated to improve readability</a:t>
             </a:r>
           </a:p>
         </p:txBody>
@@ -3970,7 +3939,7 @@
               </a:defRPr>
             </a:pPr>
             <a:r>
-              <a:t>Scenario estimate only, not causal guarantee</a:t>
+              <a:t>Community-aware matching for healthier shortlist diversity</a:t>
             </a:r>
           </a:p>
         </p:txBody>
@@ -4024,7 +3993,7 @@
               </a:defRPr>
             </a:pPr>
             <a:r>
-              <a:t>Live Demo Flow</a:t>
+              <a:t>ROI Scenario (Business Lens)</a:t>
             </a:r>
           </a:p>
         </p:txBody>
@@ -4072,16 +4041,121 @@
           </a:p>
         </p:txBody>
       </p:sp>
-      <p:sp>
-        <p:nvSpPr>
-          <p:cNvPr id="4" name="TextBox 3"/>
+      <p:pic>
+        <p:nvPicPr>
+          <p:cNvPr id="4" name="Picture 3" descr="roi_funnel_base.png"/>
+          <p:cNvPicPr>
+            <a:picLocks noChangeAspect="1"/>
+          </p:cNvPicPr>
+          <p:nvPr/>
+        </p:nvPicPr>
+        <p:blipFill>
+          <a:blip r:embed="rId2"/>
+          <a:stretch>
+            <a:fillRect/>
+          </a:stretch>
+        </p:blipFill>
+        <p:spPr>
+          <a:xfrm>
+            <a:off x="685800" y="1828800"/>
+            <a:ext cx="8046720" cy="4480560"/>
+          </a:xfrm>
+          <a:prstGeom prst="rect">
+            <a:avLst/>
+          </a:prstGeom>
+        </p:spPr>
+      </p:pic>
+      <p:sp>
+        <p:nvSpPr>
+          <p:cNvPr id="5" name="Rounded Rectangle 4"/>
+          <p:cNvSpPr/>
+          <p:nvPr/>
+        </p:nvSpPr>
+        <p:spPr>
+          <a:xfrm>
+            <a:off x="7178040" y="1828800"/>
+            <a:ext cx="4251960" cy="4480560"/>
+          </a:xfrm>
+          <a:prstGeom prst="roundRect">
+            <a:avLst/>
+          </a:prstGeom>
+          <a:solidFill>
+            <a:srgbClr val="F2F7FC"/>
+          </a:solidFill>
+          <a:ln w="15875">
+            <a:solidFill>
+              <a:srgbClr val="CDDCEE"/>
+            </a:solidFill>
+          </a:ln>
+        </p:spPr>
+        <p:style>
+          <a:lnRef idx="1">
+            <a:schemeClr val="accent1"/>
+          </a:lnRef>
+          <a:fillRef idx="3">
+            <a:schemeClr val="accent1"/>
+          </a:fillRef>
+          <a:effectRef idx="2">
+            <a:schemeClr val="accent1"/>
+          </a:effectRef>
+          <a:fontRef idx="minor">
+            <a:schemeClr val="lt1"/>
+          </a:fontRef>
+        </p:style>
+        <p:txBody>
+          <a:bodyPr rtlCol="0" anchor="ctr"/>
+          <a:lstStyle/>
+          <a:p>
+            <a:pPr algn="ctr"/>
+          </a:p>
+        </p:txBody>
+      </p:sp>
+      <p:sp>
+        <p:nvSpPr>
+          <p:cNvPr id="6" name="TextBox 5"/>
           <p:cNvSpPr txBox="1"/>
           <p:nvPr/>
         </p:nvSpPr>
         <p:spPr>
           <a:xfrm>
-            <a:off x="731520" y="1920240"/>
-            <a:ext cx="10972800" cy="4297680"/>
+            <a:off x="7379208" y="1938528"/>
+            <a:ext cx="3931920" cy="365760"/>
+          </a:xfrm>
+          <a:prstGeom prst="rect">
+            <a:avLst/>
+          </a:prstGeom>
+          <a:noFill/>
+        </p:spPr>
+        <p:txBody>
+          <a:bodyPr wrap="none">
+            <a:spAutoFit/>
+          </a:bodyPr>
+          <a:lstStyle/>
+          <a:p>
+            <a:pPr>
+              <a:defRPr b="1" sz="1900">
+                <a:solidFill>
+                  <a:srgbClr val="133A66"/>
+                </a:solidFill>
+                <a:latin typeface="Aptos"/>
+              </a:defRPr>
+            </a:pPr>
+            <a:r>
+              <a:t>Base scenario outputs</a:t>
+            </a:r>
+          </a:p>
+        </p:txBody>
+      </p:sp>
+      <p:sp>
+        <p:nvSpPr>
+          <p:cNvPr id="7" name="TextBox 6"/>
+          <p:cNvSpPr txBox="1"/>
+          <p:nvPr/>
+        </p:nvSpPr>
+        <p:spPr>
+          <a:xfrm>
+            <a:off x="7360919" y="2304288"/>
+            <a:ext cx="3931920" cy="3913632"/>
           </a:xfrm>
           <a:prstGeom prst="rect">
             <a:avLst/>
@@ -4098,7 +4172,7 @@
               <a:spcAft>
                 <a:spcPts val="900"/>
               </a:spcAft>
-              <a:defRPr sz="1900">
+              <a:defRPr sz="1600">
                 <a:solidFill>
                   <a:srgbClr val="1C2D46"/>
                 </a:solidFill>
@@ -4106,7 +4180,7 @@
               </a:defRPr>
             </a:pPr>
             <a:r>
-              <a:t>1) Enter campaign input (brand/product/audience/keywords/budget)</a:t>
+              <a:t>Budget: $50,000</a:t>
             </a:r>
           </a:p>
           <a:p>
@@ -4114,7 +4188,7 @@
               <a:spcAft>
                 <a:spcPts val="900"/>
               </a:spcAft>
-              <a:defRPr sz="1900">
+              <a:defRPr sz="1600">
                 <a:solidFill>
                   <a:srgbClr val="1C2D46"/>
                 </a:solidFill>
@@ -4122,7 +4196,7 @@
               </a:defRPr>
             </a:pPr>
             <a:r>
-              <a:t>2) Run analysis and show analyzing workflow</a:t>
+              <a:t>Impressions: 2,777,777</a:t>
             </a:r>
           </a:p>
           <a:p>
@@ -4130,7 +4204,7 @@
               <a:spcAft>
                 <a:spcPts val="900"/>
               </a:spcAft>
-              <a:defRPr sz="1900">
+              <a:defRPr sz="1600">
                 <a:solidFill>
                   <a:srgbClr val="1C2D46"/>
                 </a:solidFill>
@@ -4138,7 +4212,7 @@
               </a:defRPr>
             </a:pPr>
             <a:r>
-              <a:t>3) Inspect Top-N cards with rationale and evidence</a:t>
+              <a:t>Clicks: 49,999</a:t>
             </a:r>
           </a:p>
           <a:p>
@@ -4146,7 +4220,7 @@
               <a:spcAft>
                 <a:spcPts val="900"/>
               </a:spcAft>
-              <a:defRPr sz="1900">
+              <a:defRPr sz="1600">
                 <a:solidFill>
                   <a:srgbClr val="1C2D46"/>
                 </a:solidFill>
@@ -4154,7 +4228,7 @@
               </a:defRPr>
             </a:pPr>
             <a:r>
-              <a:t>4) Change ranking strategy and diversity controls</a:t>
+              <a:t>Conversions: 1,499</a:t>
             </a:r>
           </a:p>
           <a:p>
@@ -4162,7 +4236,7 @@
               <a:spcAft>
                 <a:spcPts val="900"/>
               </a:spcAft>
-              <a:defRPr sz="1900">
+              <a:defRPr sz="1600">
                 <a:solidFill>
                   <a:srgbClr val="1C2D46"/>
                 </a:solidFill>
@@ -4170,46 +4244,14 @@
               </a:defRPr>
             </a:pPr>
             <a:r>
-              <a:t>5) Explore Text Intelligence and Network Studio</a:t>
-            </a:r>
-          </a:p>
-          <a:p>
-            <a:pPr>
-              <a:spcAft>
-                <a:spcPts val="900"/>
-              </a:spcAft>
-              <a:defRPr sz="1900">
-                <a:solidFill>
-                  <a:srgbClr val="1C2D46"/>
-                </a:solidFill>
-                <a:latin typeface="Aptos"/>
-              </a:defRPr>
-            </a:pPr>
-            <a:r>
-              <a:t>6) Review ML Studio (model comparison + SHAP)</a:t>
-            </a:r>
-          </a:p>
-          <a:p>
-            <a:pPr>
-              <a:spcAft>
-                <a:spcPts val="900"/>
-              </a:spcAft>
-              <a:defRPr sz="1900">
-                <a:solidFill>
-                  <a:srgbClr val="1C2D46"/>
-                </a:solidFill>
-                <a:latin typeface="Aptos"/>
-              </a:defRPr>
-            </a:pPr>
-            <a:r>
-              <a:t>7) Adjust ROI assumptions and export memo</a:t>
-            </a:r>
-          </a:p>
-        </p:txBody>
-      </p:sp>
-      <p:sp>
-        <p:nvSpPr>
-          <p:cNvPr id="5" name="TextBox 4"/>
+              <a:t>Expected ROAS: 1.14x</a:t>
+            </a:r>
+          </a:p>
+        </p:txBody>
+      </p:sp>
+      <p:sp>
+        <p:nvSpPr>
+          <p:cNvPr id="8" name="TextBox 7"/>
           <p:cNvSpPr txBox="1"/>
           <p:nvPr/>
         </p:nvSpPr>
@@ -4238,7 +4280,7 @@
               </a:defRPr>
             </a:pPr>
             <a:r>
-              <a:t>Rubric 4: Demo clarity and storytelling flow</a:t>
+              <a:t>Scenario estimate only, not causal guarantee</a:t>
             </a:r>
           </a:p>
         </p:txBody>
@@ -4292,7 +4334,7 @@
               </a:defRPr>
             </a:pPr>
             <a:r>
-              <a:t>Limitations and Future Work</a:t>
+              <a:t>Live Demo Flow</a:t>
             </a:r>
           </a:p>
         </p:txBody>
@@ -4342,46 +4384,136 @@
       </p:sp>
       <p:sp>
         <p:nvSpPr>
-          <p:cNvPr id="4" name="Rounded Rectangle 3"/>
-          <p:cNvSpPr/>
-          <p:nvPr/>
-        </p:nvSpPr>
-        <p:spPr>
-          <a:xfrm>
-            <a:off x="640080" y="1828800"/>
-            <a:ext cx="5440680" cy="4389120"/>
-          </a:xfrm>
-          <a:prstGeom prst="roundRect">
-            <a:avLst/>
-          </a:prstGeom>
-          <a:solidFill>
-            <a:srgbClr val="F2F7FC"/>
-          </a:solidFill>
-          <a:ln w="15875">
-            <a:solidFill>
-              <a:srgbClr val="CDDCEE"/>
-            </a:solidFill>
-          </a:ln>
-        </p:spPr>
-        <p:style>
-          <a:lnRef idx="1">
-            <a:schemeClr val="accent1"/>
-          </a:lnRef>
-          <a:fillRef idx="3">
-            <a:schemeClr val="accent1"/>
-          </a:fillRef>
-          <a:effectRef idx="2">
-            <a:schemeClr val="accent1"/>
-          </a:effectRef>
-          <a:fontRef idx="minor">
-            <a:schemeClr val="lt1"/>
-          </a:fontRef>
-        </p:style>
-        <p:txBody>
-          <a:bodyPr rtlCol="0" anchor="ctr"/>
-          <a:lstStyle/>
-          <a:p>
-            <a:pPr algn="ctr"/>
+          <p:cNvPr id="4" name="TextBox 3"/>
+          <p:cNvSpPr txBox="1"/>
+          <p:nvPr/>
+        </p:nvSpPr>
+        <p:spPr>
+          <a:xfrm>
+            <a:off x="731520" y="1920240"/>
+            <a:ext cx="10972800" cy="4297680"/>
+          </a:xfrm>
+          <a:prstGeom prst="rect">
+            <a:avLst/>
+          </a:prstGeom>
+          <a:noFill/>
+        </p:spPr>
+        <p:txBody>
+          <a:bodyPr wrap="square">
+            <a:spAutoFit/>
+          </a:bodyPr>
+          <a:lstStyle/>
+          <a:p>
+            <a:pPr>
+              <a:spcAft>
+                <a:spcPts val="900"/>
+              </a:spcAft>
+              <a:defRPr sz="1900">
+                <a:solidFill>
+                  <a:srgbClr val="1C2D46"/>
+                </a:solidFill>
+                <a:latin typeface="Aptos"/>
+              </a:defRPr>
+            </a:pPr>
+            <a:r>
+              <a:t>1) Enter campaign input (brand/product/audience/keywords/budget)</a:t>
+            </a:r>
+          </a:p>
+          <a:p>
+            <a:pPr>
+              <a:spcAft>
+                <a:spcPts val="900"/>
+              </a:spcAft>
+              <a:defRPr sz="1900">
+                <a:solidFill>
+                  <a:srgbClr val="1C2D46"/>
+                </a:solidFill>
+                <a:latin typeface="Aptos"/>
+              </a:defRPr>
+            </a:pPr>
+            <a:r>
+              <a:t>2) Run analysis and show analyzing workflow</a:t>
+            </a:r>
+          </a:p>
+          <a:p>
+            <a:pPr>
+              <a:spcAft>
+                <a:spcPts val="900"/>
+              </a:spcAft>
+              <a:defRPr sz="1900">
+                <a:solidFill>
+                  <a:srgbClr val="1C2D46"/>
+                </a:solidFill>
+                <a:latin typeface="Aptos"/>
+              </a:defRPr>
+            </a:pPr>
+            <a:r>
+              <a:t>3) Inspect Top-N cards with rationale and evidence</a:t>
+            </a:r>
+          </a:p>
+          <a:p>
+            <a:pPr>
+              <a:spcAft>
+                <a:spcPts val="900"/>
+              </a:spcAft>
+              <a:defRPr sz="1900">
+                <a:solidFill>
+                  <a:srgbClr val="1C2D46"/>
+                </a:solidFill>
+                <a:latin typeface="Aptos"/>
+              </a:defRPr>
+            </a:pPr>
+            <a:r>
+              <a:t>4) Change ranking strategy and diversity controls</a:t>
+            </a:r>
+          </a:p>
+          <a:p>
+            <a:pPr>
+              <a:spcAft>
+                <a:spcPts val="900"/>
+              </a:spcAft>
+              <a:defRPr sz="1900">
+                <a:solidFill>
+                  <a:srgbClr val="1C2D46"/>
+                </a:solidFill>
+                <a:latin typeface="Aptos"/>
+              </a:defRPr>
+            </a:pPr>
+            <a:r>
+              <a:t>5) Explore Text Intelligence and Network Studio</a:t>
+            </a:r>
+          </a:p>
+          <a:p>
+            <a:pPr>
+              <a:spcAft>
+                <a:spcPts val="900"/>
+              </a:spcAft>
+              <a:defRPr sz="1900">
+                <a:solidFill>
+                  <a:srgbClr val="1C2D46"/>
+                </a:solidFill>
+                <a:latin typeface="Aptos"/>
+              </a:defRPr>
+            </a:pPr>
+            <a:r>
+              <a:t>6) Review ML Studio (model comparison + SHAP)</a:t>
+            </a:r>
+          </a:p>
+          <a:p>
+            <a:pPr>
+              <a:spcAft>
+                <a:spcPts val="900"/>
+              </a:spcAft>
+              <a:defRPr sz="1900">
+                <a:solidFill>
+                  <a:srgbClr val="1C2D46"/>
+                </a:solidFill>
+                <a:latin typeface="Aptos"/>
+              </a:defRPr>
+            </a:pPr>
+            <a:r>
+              <a:t>7) Adjust ROI assumptions and export memo</a:t>
+            </a:r>
           </a:p>
         </p:txBody>
       </p:sp>
@@ -4393,8 +4525,8 @@
         </p:nvSpPr>
         <p:spPr>
           <a:xfrm>
-            <a:off x="841247" y="1938528"/>
-            <a:ext cx="5120640" cy="365760"/>
+            <a:off x="502920" y="6428232"/>
+            <a:ext cx="10972800" cy="292608"/>
           </a:xfrm>
           <a:prstGeom prst="rect">
             <a:avLst/>
@@ -4407,265 +4539,6 @@
           </a:bodyPr>
           <a:lstStyle/>
           <a:p>
-            <a:pPr>
-              <a:defRPr b="1" sz="1900">
-                <a:solidFill>
-                  <a:srgbClr val="133A66"/>
-                </a:solidFill>
-                <a:latin typeface="Aptos"/>
-              </a:defRPr>
-            </a:pPr>
-            <a:r>
-              <a:t>Current limitations</a:t>
-            </a:r>
-          </a:p>
-        </p:txBody>
-      </p:sp>
-      <p:sp>
-        <p:nvSpPr>
-          <p:cNvPr id="6" name="TextBox 5"/>
-          <p:cNvSpPr txBox="1"/>
-          <p:nvPr/>
-        </p:nvSpPr>
-        <p:spPr>
-          <a:xfrm>
-            <a:off x="822959" y="2304288"/>
-            <a:ext cx="5120640" cy="3822191"/>
-          </a:xfrm>
-          <a:prstGeom prst="rect">
-            <a:avLst/>
-          </a:prstGeom>
-          <a:noFill/>
-        </p:spPr>
-        <p:txBody>
-          <a:bodyPr wrap="square">
-            <a:spAutoFit/>
-          </a:bodyPr>
-          <a:lstStyle/>
-          <a:p>
-            <a:pPr>
-              <a:spcAft>
-                <a:spcPts val="900"/>
-              </a:spcAft>
-              <a:defRPr sz="1600">
-                <a:solidFill>
-                  <a:srgbClr val="1C2D46"/>
-                </a:solidFill>
-                <a:latin typeface="Aptos"/>
-              </a:defRPr>
-            </a:pPr>
-            <a:r>
-              <a:t>Prototype uses pre-collected YouTube data.</a:t>
-            </a:r>
-          </a:p>
-          <a:p>
-            <a:pPr>
-              <a:spcAft>
-                <a:spcPts val="900"/>
-              </a:spcAft>
-              <a:defRPr sz="1600">
-                <a:solidFill>
-                  <a:srgbClr val="1C2D46"/>
-                </a:solidFill>
-                <a:latin typeface="Aptos"/>
-              </a:defRPr>
-            </a:pPr>
-            <a:r>
-              <a:t>ROI module is scenario simulation, not causal inference.</a:t>
-            </a:r>
-          </a:p>
-          <a:p>
-            <a:pPr>
-              <a:spcAft>
-                <a:spcPts val="900"/>
-              </a:spcAft>
-              <a:defRPr sz="1600">
-                <a:solidFill>
-                  <a:srgbClr val="1C2D46"/>
-                </a:solidFill>
-                <a:latin typeface="Aptos"/>
-              </a:defRPr>
-            </a:pPr>
-            <a:r>
-              <a:t>Cluster concentration still exists in skincare-heavy niches.</a:t>
-            </a:r>
-          </a:p>
-        </p:txBody>
-      </p:sp>
-      <p:sp>
-        <p:nvSpPr>
-          <p:cNvPr id="7" name="Rounded Rectangle 6"/>
-          <p:cNvSpPr/>
-          <p:nvPr/>
-        </p:nvSpPr>
-        <p:spPr>
-          <a:xfrm>
-            <a:off x="6172200" y="1828800"/>
-            <a:ext cx="5440680" cy="4389120"/>
-          </a:xfrm>
-          <a:prstGeom prst="roundRect">
-            <a:avLst/>
-          </a:prstGeom>
-          <a:solidFill>
-            <a:srgbClr val="F2F7FC"/>
-          </a:solidFill>
-          <a:ln w="15875">
-            <a:solidFill>
-              <a:srgbClr val="CDDCEE"/>
-            </a:solidFill>
-          </a:ln>
-        </p:spPr>
-        <p:style>
-          <a:lnRef idx="1">
-            <a:schemeClr val="accent1"/>
-          </a:lnRef>
-          <a:fillRef idx="3">
-            <a:schemeClr val="accent1"/>
-          </a:fillRef>
-          <a:effectRef idx="2">
-            <a:schemeClr val="accent1"/>
-          </a:effectRef>
-          <a:fontRef idx="minor">
-            <a:schemeClr val="lt1"/>
-          </a:fontRef>
-        </p:style>
-        <p:txBody>
-          <a:bodyPr rtlCol="0" anchor="ctr"/>
-          <a:lstStyle/>
-          <a:p>
-            <a:pPr algn="ctr"/>
-          </a:p>
-        </p:txBody>
-      </p:sp>
-      <p:sp>
-        <p:nvSpPr>
-          <p:cNvPr id="8" name="TextBox 7"/>
-          <p:cNvSpPr txBox="1"/>
-          <p:nvPr/>
-        </p:nvSpPr>
-        <p:spPr>
-          <a:xfrm>
-            <a:off x="6373368" y="1938528"/>
-            <a:ext cx="5120640" cy="365760"/>
-          </a:xfrm>
-          <a:prstGeom prst="rect">
-            <a:avLst/>
-          </a:prstGeom>
-          <a:noFill/>
-        </p:spPr>
-        <p:txBody>
-          <a:bodyPr wrap="none">
-            <a:spAutoFit/>
-          </a:bodyPr>
-          <a:lstStyle/>
-          <a:p>
-            <a:pPr>
-              <a:defRPr b="1" sz="1900">
-                <a:solidFill>
-                  <a:srgbClr val="133A66"/>
-                </a:solidFill>
-                <a:latin typeface="Aptos"/>
-              </a:defRPr>
-            </a:pPr>
-            <a:r>
-              <a:t>Next steps</a:t>
-            </a:r>
-          </a:p>
-        </p:txBody>
-      </p:sp>
-      <p:sp>
-        <p:nvSpPr>
-          <p:cNvPr id="9" name="TextBox 8"/>
-          <p:cNvSpPr txBox="1"/>
-          <p:nvPr/>
-        </p:nvSpPr>
-        <p:spPr>
-          <a:xfrm>
-            <a:off x="6355080" y="2304288"/>
-            <a:ext cx="5120640" cy="3822191"/>
-          </a:xfrm>
-          <a:prstGeom prst="rect">
-            <a:avLst/>
-          </a:prstGeom>
-          <a:noFill/>
-        </p:spPr>
-        <p:txBody>
-          <a:bodyPr wrap="square">
-            <a:spAutoFit/>
-          </a:bodyPr>
-          <a:lstStyle/>
-          <a:p>
-            <a:pPr>
-              <a:spcAft>
-                <a:spcPts val="900"/>
-              </a:spcAft>
-              <a:defRPr sz="1600">
-                <a:solidFill>
-                  <a:srgbClr val="1C2D46"/>
-                </a:solidFill>
-                <a:latin typeface="Aptos"/>
-              </a:defRPr>
-            </a:pPr>
-            <a:r>
-              <a:t>Add live market and competitor enrichment.</a:t>
-            </a:r>
-          </a:p>
-          <a:p>
-            <a:pPr>
-              <a:spcAft>
-                <a:spcPts val="900"/>
-              </a:spcAft>
-              <a:defRPr sz="1600">
-                <a:solidFill>
-                  <a:srgbClr val="1C2D46"/>
-                </a:solidFill>
-                <a:latin typeface="Aptos"/>
-              </a:defRPr>
-            </a:pPr>
-            <a:r>
-              <a:t>Expand to TikTok/Instagram connectors.</a:t>
-            </a:r>
-          </a:p>
-          <a:p>
-            <a:pPr>
-              <a:spcAft>
-                <a:spcPts val="900"/>
-              </a:spcAft>
-              <a:defRPr sz="1600">
-                <a:solidFill>
-                  <a:srgbClr val="1C2D46"/>
-                </a:solidFill>
-                <a:latin typeface="Aptos"/>
-              </a:defRPr>
-            </a:pPr>
-            <a:r>
-              <a:t>Introduce experiment loop for closed-loop learning.</a:t>
-            </a:r>
-          </a:p>
-        </p:txBody>
-      </p:sp>
-      <p:sp>
-        <p:nvSpPr>
-          <p:cNvPr id="10" name="TextBox 9"/>
-          <p:cNvSpPr txBox="1"/>
-          <p:nvPr/>
-        </p:nvSpPr>
-        <p:spPr>
-          <a:xfrm>
-            <a:off x="502920" y="6428232"/>
-            <a:ext cx="10972800" cy="292608"/>
-          </a:xfrm>
-          <a:prstGeom prst="rect">
-            <a:avLst/>
-          </a:prstGeom>
-          <a:noFill/>
-        </p:spPr>
-        <p:txBody>
-          <a:bodyPr wrap="none">
-            <a:spAutoFit/>
-          </a:bodyPr>
-          <a:lstStyle/>
-          <a:p>
             <a:pPr algn="r">
               <a:defRPr sz="1000">
                 <a:solidFill>
@@ -4675,7 +4548,7 @@
               </a:defRPr>
             </a:pPr>
             <a:r>
-              <a:t>Honest caveats + practical roadmap</a:t>
+              <a:t>Rubric 4: Demo clarity and storytelling flow</a:t>
             </a:r>
           </a:p>
         </p:txBody>
@@ -4689,6 +4562,443 @@
 </file>
 
 <file path=ppt/slides/slide14.xml><?xml version="1.0" encoding="utf-8"?>
+<p:sld xmlns:a="http://schemas.openxmlformats.org/drawingml/2006/main" xmlns:p="http://schemas.openxmlformats.org/presentationml/2006/main" xmlns:r="http://schemas.openxmlformats.org/officeDocument/2006/relationships">
+  <p:cSld>
+    <p:spTree>
+      <p:nvGrpSpPr>
+        <p:cNvPr id="1" name=""/>
+        <p:cNvGrpSpPr/>
+        <p:nvPr/>
+      </p:nvGrpSpPr>
+      <p:grpSpPr/>
+      <p:sp>
+        <p:nvSpPr>
+          <p:cNvPr id="2" name="TextBox 1"/>
+          <p:cNvSpPr txBox="1"/>
+          <p:nvPr/>
+        </p:nvSpPr>
+        <p:spPr>
+          <a:xfrm>
+            <a:off x="594360" y="320040"/>
+            <a:ext cx="11064240" cy="914400"/>
+          </a:xfrm>
+          <a:prstGeom prst="rect">
+            <a:avLst/>
+          </a:prstGeom>
+          <a:noFill/>
+        </p:spPr>
+        <p:txBody>
+          <a:bodyPr wrap="none">
+            <a:spAutoFit/>
+          </a:bodyPr>
+          <a:lstStyle/>
+          <a:p>
+            <a:pPr>
+              <a:defRPr sz="3400" b="1">
+                <a:solidFill>
+                  <a:srgbClr val="0F2C59"/>
+                </a:solidFill>
+                <a:latin typeface="Aptos Display"/>
+              </a:defRPr>
+            </a:pPr>
+            <a:r>
+              <a:t>Limitations and Future Work</a:t>
+            </a:r>
+          </a:p>
+        </p:txBody>
+      </p:sp>
+      <p:sp>
+        <p:nvSpPr>
+          <p:cNvPr id="3" name="Rectangle 2"/>
+          <p:cNvSpPr/>
+          <p:nvPr/>
+        </p:nvSpPr>
+        <p:spPr>
+          <a:xfrm>
+            <a:off x="566928" y="1783080"/>
+            <a:ext cx="2377440" cy="73152"/>
+          </a:xfrm>
+          <a:prstGeom prst="rect">
+            <a:avLst/>
+          </a:prstGeom>
+          <a:solidFill>
+            <a:srgbClr val="1A7DBC"/>
+          </a:solidFill>
+          <a:ln>
+            <a:noFill/>
+          </a:ln>
+        </p:spPr>
+        <p:style>
+          <a:lnRef idx="1">
+            <a:schemeClr val="accent1"/>
+          </a:lnRef>
+          <a:fillRef idx="3">
+            <a:schemeClr val="accent1"/>
+          </a:fillRef>
+          <a:effectRef idx="2">
+            <a:schemeClr val="accent1"/>
+          </a:effectRef>
+          <a:fontRef idx="minor">
+            <a:schemeClr val="lt1"/>
+          </a:fontRef>
+        </p:style>
+        <p:txBody>
+          <a:bodyPr rtlCol="0" anchor="ctr"/>
+          <a:lstStyle/>
+          <a:p>
+            <a:pPr algn="ctr"/>
+          </a:p>
+        </p:txBody>
+      </p:sp>
+      <p:sp>
+        <p:nvSpPr>
+          <p:cNvPr id="4" name="Rounded Rectangle 3"/>
+          <p:cNvSpPr/>
+          <p:nvPr/>
+        </p:nvSpPr>
+        <p:spPr>
+          <a:xfrm>
+            <a:off x="640080" y="1828800"/>
+            <a:ext cx="5440680" cy="4389120"/>
+          </a:xfrm>
+          <a:prstGeom prst="roundRect">
+            <a:avLst/>
+          </a:prstGeom>
+          <a:solidFill>
+            <a:srgbClr val="F2F7FC"/>
+          </a:solidFill>
+          <a:ln w="15875">
+            <a:solidFill>
+              <a:srgbClr val="CDDCEE"/>
+            </a:solidFill>
+          </a:ln>
+        </p:spPr>
+        <p:style>
+          <a:lnRef idx="1">
+            <a:schemeClr val="accent1"/>
+          </a:lnRef>
+          <a:fillRef idx="3">
+            <a:schemeClr val="accent1"/>
+          </a:fillRef>
+          <a:effectRef idx="2">
+            <a:schemeClr val="accent1"/>
+          </a:effectRef>
+          <a:fontRef idx="minor">
+            <a:schemeClr val="lt1"/>
+          </a:fontRef>
+        </p:style>
+        <p:txBody>
+          <a:bodyPr rtlCol="0" anchor="ctr"/>
+          <a:lstStyle/>
+          <a:p>
+            <a:pPr algn="ctr"/>
+          </a:p>
+        </p:txBody>
+      </p:sp>
+      <p:sp>
+        <p:nvSpPr>
+          <p:cNvPr id="5" name="TextBox 4"/>
+          <p:cNvSpPr txBox="1"/>
+          <p:nvPr/>
+        </p:nvSpPr>
+        <p:spPr>
+          <a:xfrm>
+            <a:off x="841247" y="1938528"/>
+            <a:ext cx="5120640" cy="365760"/>
+          </a:xfrm>
+          <a:prstGeom prst="rect">
+            <a:avLst/>
+          </a:prstGeom>
+          <a:noFill/>
+        </p:spPr>
+        <p:txBody>
+          <a:bodyPr wrap="none">
+            <a:spAutoFit/>
+          </a:bodyPr>
+          <a:lstStyle/>
+          <a:p>
+            <a:pPr>
+              <a:defRPr b="1" sz="1900">
+                <a:solidFill>
+                  <a:srgbClr val="133A66"/>
+                </a:solidFill>
+                <a:latin typeface="Aptos"/>
+              </a:defRPr>
+            </a:pPr>
+            <a:r>
+              <a:t>Current limitations</a:t>
+            </a:r>
+          </a:p>
+        </p:txBody>
+      </p:sp>
+      <p:sp>
+        <p:nvSpPr>
+          <p:cNvPr id="6" name="TextBox 5"/>
+          <p:cNvSpPr txBox="1"/>
+          <p:nvPr/>
+        </p:nvSpPr>
+        <p:spPr>
+          <a:xfrm>
+            <a:off x="822959" y="2304288"/>
+            <a:ext cx="5120640" cy="3822191"/>
+          </a:xfrm>
+          <a:prstGeom prst="rect">
+            <a:avLst/>
+          </a:prstGeom>
+          <a:noFill/>
+        </p:spPr>
+        <p:txBody>
+          <a:bodyPr wrap="square">
+            <a:spAutoFit/>
+          </a:bodyPr>
+          <a:lstStyle/>
+          <a:p>
+            <a:pPr>
+              <a:spcAft>
+                <a:spcPts val="900"/>
+              </a:spcAft>
+              <a:defRPr sz="1600">
+                <a:solidFill>
+                  <a:srgbClr val="1C2D46"/>
+                </a:solidFill>
+                <a:latin typeface="Aptos"/>
+              </a:defRPr>
+            </a:pPr>
+            <a:r>
+              <a:t>Prototype uses pre-collected YouTube data.</a:t>
+            </a:r>
+          </a:p>
+          <a:p>
+            <a:pPr>
+              <a:spcAft>
+                <a:spcPts val="900"/>
+              </a:spcAft>
+              <a:defRPr sz="1600">
+                <a:solidFill>
+                  <a:srgbClr val="1C2D46"/>
+                </a:solidFill>
+                <a:latin typeface="Aptos"/>
+              </a:defRPr>
+            </a:pPr>
+            <a:r>
+              <a:t>ROI module is scenario simulation, not causal inference.</a:t>
+            </a:r>
+          </a:p>
+          <a:p>
+            <a:pPr>
+              <a:spcAft>
+                <a:spcPts val="900"/>
+              </a:spcAft>
+              <a:defRPr sz="1600">
+                <a:solidFill>
+                  <a:srgbClr val="1C2D46"/>
+                </a:solidFill>
+                <a:latin typeface="Aptos"/>
+              </a:defRPr>
+            </a:pPr>
+            <a:r>
+              <a:t>Cluster concentration still exists in skincare-heavy niches.</a:t>
+            </a:r>
+          </a:p>
+        </p:txBody>
+      </p:sp>
+      <p:sp>
+        <p:nvSpPr>
+          <p:cNvPr id="7" name="Rounded Rectangle 6"/>
+          <p:cNvSpPr/>
+          <p:nvPr/>
+        </p:nvSpPr>
+        <p:spPr>
+          <a:xfrm>
+            <a:off x="6172200" y="1828800"/>
+            <a:ext cx="5440680" cy="4389120"/>
+          </a:xfrm>
+          <a:prstGeom prst="roundRect">
+            <a:avLst/>
+          </a:prstGeom>
+          <a:solidFill>
+            <a:srgbClr val="F2F7FC"/>
+          </a:solidFill>
+          <a:ln w="15875">
+            <a:solidFill>
+              <a:srgbClr val="CDDCEE"/>
+            </a:solidFill>
+          </a:ln>
+        </p:spPr>
+        <p:style>
+          <a:lnRef idx="1">
+            <a:schemeClr val="accent1"/>
+          </a:lnRef>
+          <a:fillRef idx="3">
+            <a:schemeClr val="accent1"/>
+          </a:fillRef>
+          <a:effectRef idx="2">
+            <a:schemeClr val="accent1"/>
+          </a:effectRef>
+          <a:fontRef idx="minor">
+            <a:schemeClr val="lt1"/>
+          </a:fontRef>
+        </p:style>
+        <p:txBody>
+          <a:bodyPr rtlCol="0" anchor="ctr"/>
+          <a:lstStyle/>
+          <a:p>
+            <a:pPr algn="ctr"/>
+          </a:p>
+        </p:txBody>
+      </p:sp>
+      <p:sp>
+        <p:nvSpPr>
+          <p:cNvPr id="8" name="TextBox 7"/>
+          <p:cNvSpPr txBox="1"/>
+          <p:nvPr/>
+        </p:nvSpPr>
+        <p:spPr>
+          <a:xfrm>
+            <a:off x="6373368" y="1938528"/>
+            <a:ext cx="5120640" cy="365760"/>
+          </a:xfrm>
+          <a:prstGeom prst="rect">
+            <a:avLst/>
+          </a:prstGeom>
+          <a:noFill/>
+        </p:spPr>
+        <p:txBody>
+          <a:bodyPr wrap="none">
+            <a:spAutoFit/>
+          </a:bodyPr>
+          <a:lstStyle/>
+          <a:p>
+            <a:pPr>
+              <a:defRPr b="1" sz="1900">
+                <a:solidFill>
+                  <a:srgbClr val="133A66"/>
+                </a:solidFill>
+                <a:latin typeface="Aptos"/>
+              </a:defRPr>
+            </a:pPr>
+            <a:r>
+              <a:t>Next steps</a:t>
+            </a:r>
+          </a:p>
+        </p:txBody>
+      </p:sp>
+      <p:sp>
+        <p:nvSpPr>
+          <p:cNvPr id="9" name="TextBox 8"/>
+          <p:cNvSpPr txBox="1"/>
+          <p:nvPr/>
+        </p:nvSpPr>
+        <p:spPr>
+          <a:xfrm>
+            <a:off x="6355080" y="2304288"/>
+            <a:ext cx="5120640" cy="3822191"/>
+          </a:xfrm>
+          <a:prstGeom prst="rect">
+            <a:avLst/>
+          </a:prstGeom>
+          <a:noFill/>
+        </p:spPr>
+        <p:txBody>
+          <a:bodyPr wrap="square">
+            <a:spAutoFit/>
+          </a:bodyPr>
+          <a:lstStyle/>
+          <a:p>
+            <a:pPr>
+              <a:spcAft>
+                <a:spcPts val="900"/>
+              </a:spcAft>
+              <a:defRPr sz="1600">
+                <a:solidFill>
+                  <a:srgbClr val="1C2D46"/>
+                </a:solidFill>
+                <a:latin typeface="Aptos"/>
+              </a:defRPr>
+            </a:pPr>
+            <a:r>
+              <a:t>Add live market and competitor enrichment.</a:t>
+            </a:r>
+          </a:p>
+          <a:p>
+            <a:pPr>
+              <a:spcAft>
+                <a:spcPts val="900"/>
+              </a:spcAft>
+              <a:defRPr sz="1600">
+                <a:solidFill>
+                  <a:srgbClr val="1C2D46"/>
+                </a:solidFill>
+                <a:latin typeface="Aptos"/>
+              </a:defRPr>
+            </a:pPr>
+            <a:r>
+              <a:t>Expand to TikTok/Instagram connectors.</a:t>
+            </a:r>
+          </a:p>
+          <a:p>
+            <a:pPr>
+              <a:spcAft>
+                <a:spcPts val="900"/>
+              </a:spcAft>
+              <a:defRPr sz="1600">
+                <a:solidFill>
+                  <a:srgbClr val="1C2D46"/>
+                </a:solidFill>
+                <a:latin typeface="Aptos"/>
+              </a:defRPr>
+            </a:pPr>
+            <a:r>
+              <a:t>Introduce experiment loop for closed-loop learning.</a:t>
+            </a:r>
+          </a:p>
+        </p:txBody>
+      </p:sp>
+      <p:sp>
+        <p:nvSpPr>
+          <p:cNvPr id="10" name="TextBox 9"/>
+          <p:cNvSpPr txBox="1"/>
+          <p:nvPr/>
+        </p:nvSpPr>
+        <p:spPr>
+          <a:xfrm>
+            <a:off x="502920" y="6428232"/>
+            <a:ext cx="10972800" cy="292608"/>
+          </a:xfrm>
+          <a:prstGeom prst="rect">
+            <a:avLst/>
+          </a:prstGeom>
+          <a:noFill/>
+        </p:spPr>
+        <p:txBody>
+          <a:bodyPr wrap="none">
+            <a:spAutoFit/>
+          </a:bodyPr>
+          <a:lstStyle/>
+          <a:p>
+            <a:pPr algn="r">
+              <a:defRPr sz="1000">
+                <a:solidFill>
+                  <a:srgbClr val="6E8098"/>
+                </a:solidFill>
+                <a:latin typeface="Aptos"/>
+              </a:defRPr>
+            </a:pPr>
+            <a:r>
+              <a:t>Honest caveats + practical roadmap</a:t>
+            </a:r>
+          </a:p>
+        </p:txBody>
+      </p:sp>
+    </p:spTree>
+  </p:cSld>
+  <p:clrMapOvr>
+    <a:masterClrMapping/>
+  </p:clrMapOvr>
+</p:sld>
+</file>
+
+<file path=ppt/slides/slide15.xml><?xml version="1.0" encoding="utf-8"?>
 <p:sld xmlns:a="http://schemas.openxmlformats.org/drawingml/2006/main" xmlns:p="http://schemas.openxmlformats.org/presentationml/2006/main" xmlns:r="http://schemas.openxmlformats.org/officeDocument/2006/relationships">
   <p:cSld>
     <p:spTree>
@@ -5057,7 +5367,7 @@
 </p:sld>
 </file>
 
-<file path=ppt/slides/slide15.xml><?xml version="1.0" encoding="utf-8"?>
+<file path=ppt/slides/slide16.xml><?xml version="1.0" encoding="utf-8"?>
 <p:sld xmlns:a="http://schemas.openxmlformats.org/drawingml/2006/main" xmlns:p="http://schemas.openxmlformats.org/presentationml/2006/main" xmlns:r="http://schemas.openxmlformats.org/officeDocument/2006/relationships">
   <p:cSld>
     <p:spTree>
@@ -5429,7 +5739,7 @@
 </p:sld>
 </file>
 
-<file path=ppt/slides/slide16.xml><?xml version="1.0" encoding="utf-8"?>
+<file path=ppt/slides/slide17.xml><?xml version="1.0" encoding="utf-8"?>
 <p:sld xmlns:a="http://schemas.openxmlformats.org/drawingml/2006/main" xmlns:p="http://schemas.openxmlformats.org/presentationml/2006/main" xmlns:r="http://schemas.openxmlformats.org/officeDocument/2006/relationships">
   <p:cSld>
     <p:spTree>
@@ -6155,6 +6465,523 @@
 </file>
 
 <file path=ppt/slides/slide3.xml><?xml version="1.0" encoding="utf-8"?>
+<p:sld xmlns:a="http://schemas.openxmlformats.org/drawingml/2006/main" xmlns:p="http://schemas.openxmlformats.org/presentationml/2006/main" xmlns:r="http://schemas.openxmlformats.org/officeDocument/2006/relationships">
+  <p:cSld>
+    <p:spTree>
+      <p:nvGrpSpPr>
+        <p:cNvPr id="1" name=""/>
+        <p:cNvGrpSpPr/>
+        <p:nvPr/>
+      </p:nvGrpSpPr>
+      <p:grpSpPr/>
+      <p:sp>
+        <p:nvSpPr>
+          <p:cNvPr id="2" name="TextBox 1"/>
+          <p:cNvSpPr txBox="1"/>
+          <p:nvPr/>
+        </p:nvSpPr>
+        <p:spPr>
+          <a:xfrm>
+            <a:off x="594360" y="320040"/>
+            <a:ext cx="11064240" cy="914400"/>
+          </a:xfrm>
+          <a:prstGeom prst="rect">
+            <a:avLst/>
+          </a:prstGeom>
+          <a:noFill/>
+        </p:spPr>
+        <p:txBody>
+          <a:bodyPr wrap="none">
+            <a:spAutoFit/>
+          </a:bodyPr>
+          <a:lstStyle/>
+          <a:p>
+            <a:pPr>
+              <a:defRPr sz="3400" b="1">
+                <a:solidFill>
+                  <a:srgbClr val="0F2C59"/>
+                </a:solidFill>
+                <a:latin typeface="Aptos Display"/>
+              </a:defRPr>
+            </a:pPr>
+            <a:r>
+              <a:t>Why Beauty of Joseon? (Selection + Research)</a:t>
+            </a:r>
+          </a:p>
+        </p:txBody>
+      </p:sp>
+      <p:sp>
+        <p:nvSpPr>
+          <p:cNvPr id="3" name="Rectangle 2"/>
+          <p:cNvSpPr/>
+          <p:nvPr/>
+        </p:nvSpPr>
+        <p:spPr>
+          <a:xfrm>
+            <a:off x="566928" y="1783080"/>
+            <a:ext cx="2377440" cy="73152"/>
+          </a:xfrm>
+          <a:prstGeom prst="rect">
+            <a:avLst/>
+          </a:prstGeom>
+          <a:solidFill>
+            <a:srgbClr val="1A7DBC"/>
+          </a:solidFill>
+          <a:ln>
+            <a:noFill/>
+          </a:ln>
+        </p:spPr>
+        <p:style>
+          <a:lnRef idx="1">
+            <a:schemeClr val="accent1"/>
+          </a:lnRef>
+          <a:fillRef idx="3">
+            <a:schemeClr val="accent1"/>
+          </a:fillRef>
+          <a:effectRef idx="2">
+            <a:schemeClr val="accent1"/>
+          </a:effectRef>
+          <a:fontRef idx="minor">
+            <a:schemeClr val="lt1"/>
+          </a:fontRef>
+        </p:style>
+        <p:txBody>
+          <a:bodyPr rtlCol="0" anchor="ctr"/>
+          <a:lstStyle/>
+          <a:p>
+            <a:pPr algn="ctr"/>
+          </a:p>
+        </p:txBody>
+      </p:sp>
+      <p:sp>
+        <p:nvSpPr>
+          <p:cNvPr id="4" name="Rounded Rectangle 3"/>
+          <p:cNvSpPr/>
+          <p:nvPr/>
+        </p:nvSpPr>
+        <p:spPr>
+          <a:xfrm>
+            <a:off x="594360" y="1828800"/>
+            <a:ext cx="5440680" cy="4343400"/>
+          </a:xfrm>
+          <a:prstGeom prst="roundRect">
+            <a:avLst/>
+          </a:prstGeom>
+          <a:solidFill>
+            <a:srgbClr val="F2F7FC"/>
+          </a:solidFill>
+          <a:ln w="15875">
+            <a:solidFill>
+              <a:srgbClr val="CDDCEE"/>
+            </a:solidFill>
+          </a:ln>
+        </p:spPr>
+        <p:style>
+          <a:lnRef idx="1">
+            <a:schemeClr val="accent1"/>
+          </a:lnRef>
+          <a:fillRef idx="3">
+            <a:schemeClr val="accent1"/>
+          </a:fillRef>
+          <a:effectRef idx="2">
+            <a:schemeClr val="accent1"/>
+          </a:effectRef>
+          <a:fontRef idx="minor">
+            <a:schemeClr val="lt1"/>
+          </a:fontRef>
+        </p:style>
+        <p:txBody>
+          <a:bodyPr rtlCol="0" anchor="ctr"/>
+          <a:lstStyle/>
+          <a:p>
+            <a:pPr algn="ctr"/>
+          </a:p>
+        </p:txBody>
+      </p:sp>
+      <p:sp>
+        <p:nvSpPr>
+          <p:cNvPr id="5" name="TextBox 4"/>
+          <p:cNvSpPr txBox="1"/>
+          <p:nvPr/>
+        </p:nvSpPr>
+        <p:spPr>
+          <a:xfrm>
+            <a:off x="795528" y="1938528"/>
+            <a:ext cx="5120640" cy="365760"/>
+          </a:xfrm>
+          <a:prstGeom prst="rect">
+            <a:avLst/>
+          </a:prstGeom>
+          <a:noFill/>
+        </p:spPr>
+        <p:txBody>
+          <a:bodyPr wrap="none">
+            <a:spAutoFit/>
+          </a:bodyPr>
+          <a:lstStyle/>
+          <a:p>
+            <a:pPr>
+              <a:defRPr b="1" sz="1900">
+                <a:solidFill>
+                  <a:srgbClr val="133A66"/>
+                </a:solidFill>
+                <a:latin typeface="Aptos"/>
+              </a:defRPr>
+            </a:pPr>
+            <a:r>
+              <a:t>Why this brand for the project</a:t>
+            </a:r>
+          </a:p>
+        </p:txBody>
+      </p:sp>
+      <p:sp>
+        <p:nvSpPr>
+          <p:cNvPr id="6" name="TextBox 5"/>
+          <p:cNvSpPr txBox="1"/>
+          <p:nvPr/>
+        </p:nvSpPr>
+        <p:spPr>
+          <a:xfrm>
+            <a:off x="777240" y="2304288"/>
+            <a:ext cx="5120640" cy="3776472"/>
+          </a:xfrm>
+          <a:prstGeom prst="rect">
+            <a:avLst/>
+          </a:prstGeom>
+          <a:noFill/>
+        </p:spPr>
+        <p:txBody>
+          <a:bodyPr wrap="square">
+            <a:spAutoFit/>
+          </a:bodyPr>
+          <a:lstStyle/>
+          <a:p>
+            <a:pPr>
+              <a:spcAft>
+                <a:spcPts val="900"/>
+              </a:spcAft>
+              <a:defRPr sz="1600">
+                <a:solidFill>
+                  <a:srgbClr val="1C2D46"/>
+                </a:solidFill>
+                <a:latin typeface="Aptos"/>
+              </a:defRPr>
+            </a:pPr>
+            <a:r>
+              <a:t>Clear campaign narrative: sunscreen + lightweight skincare.</a:t>
+            </a:r>
+          </a:p>
+          <a:p>
+            <a:pPr>
+              <a:spcAft>
+                <a:spcPts val="900"/>
+              </a:spcAft>
+              <a:defRPr sz="1600">
+                <a:solidFill>
+                  <a:srgbClr val="1C2D46"/>
+                </a:solidFill>
+                <a:latin typeface="Aptos"/>
+              </a:defRPr>
+            </a:pPr>
+            <a:r>
+              <a:t>Distinct positioning for storytelling: heritage-inspired K-beauty.</a:t>
+            </a:r>
+          </a:p>
+          <a:p>
+            <a:pPr>
+              <a:spcAft>
+                <a:spcPts val="900"/>
+              </a:spcAft>
+              <a:defRPr sz="1600">
+                <a:solidFill>
+                  <a:srgbClr val="1C2D46"/>
+                </a:solidFill>
+                <a:latin typeface="Aptos"/>
+              </a:defRPr>
+            </a:pPr>
+            <a:r>
+              <a:t>Good benchmark pair with CeraVe in the same category.</a:t>
+            </a:r>
+          </a:p>
+          <a:p>
+            <a:pPr>
+              <a:spcAft>
+                <a:spcPts val="900"/>
+              </a:spcAft>
+              <a:defRPr sz="1600">
+                <a:solidFill>
+                  <a:srgbClr val="1C2D46"/>
+                </a:solidFill>
+                <a:latin typeface="Aptos"/>
+              </a:defRPr>
+            </a:pPr>
+            <a:r>
+              <a:t>Suitable for explainable matching, not only popularity ranking.</a:t>
+            </a:r>
+          </a:p>
+        </p:txBody>
+      </p:sp>
+      <p:sp>
+        <p:nvSpPr>
+          <p:cNvPr id="7" name="Rounded Rectangle 6"/>
+          <p:cNvSpPr/>
+          <p:nvPr/>
+        </p:nvSpPr>
+        <p:spPr>
+          <a:xfrm>
+            <a:off x="6144768" y="1828800"/>
+            <a:ext cx="5440680" cy="4343400"/>
+          </a:xfrm>
+          <a:prstGeom prst="roundRect">
+            <a:avLst/>
+          </a:prstGeom>
+          <a:solidFill>
+            <a:srgbClr val="F2F7FC"/>
+          </a:solidFill>
+          <a:ln w="15875">
+            <a:solidFill>
+              <a:srgbClr val="CDDCEE"/>
+            </a:solidFill>
+          </a:ln>
+        </p:spPr>
+        <p:style>
+          <a:lnRef idx="1">
+            <a:schemeClr val="accent1"/>
+          </a:lnRef>
+          <a:fillRef idx="3">
+            <a:schemeClr val="accent1"/>
+          </a:fillRef>
+          <a:effectRef idx="2">
+            <a:schemeClr val="accent1"/>
+          </a:effectRef>
+          <a:fontRef idx="minor">
+            <a:schemeClr val="lt1"/>
+          </a:fontRef>
+        </p:style>
+        <p:txBody>
+          <a:bodyPr rtlCol="0" anchor="ctr"/>
+          <a:lstStyle/>
+          <a:p>
+            <a:pPr algn="ctr"/>
+          </a:p>
+        </p:txBody>
+      </p:sp>
+      <p:sp>
+        <p:nvSpPr>
+          <p:cNvPr id="8" name="TextBox 7"/>
+          <p:cNvSpPr txBox="1"/>
+          <p:nvPr/>
+        </p:nvSpPr>
+        <p:spPr>
+          <a:xfrm>
+            <a:off x="6345936" y="1938528"/>
+            <a:ext cx="5120640" cy="365760"/>
+          </a:xfrm>
+          <a:prstGeom prst="rect">
+            <a:avLst/>
+          </a:prstGeom>
+          <a:noFill/>
+        </p:spPr>
+        <p:txBody>
+          <a:bodyPr wrap="none">
+            <a:spAutoFit/>
+          </a:bodyPr>
+          <a:lstStyle/>
+          <a:p>
+            <a:pPr>
+              <a:defRPr b="1" sz="1900">
+                <a:solidFill>
+                  <a:srgbClr val="133A66"/>
+                </a:solidFill>
+                <a:latin typeface="Aptos"/>
+              </a:defRPr>
+            </a:pPr>
+            <a:r>
+              <a:t>Brand research and dataset evidence</a:t>
+            </a:r>
+          </a:p>
+        </p:txBody>
+      </p:sp>
+      <p:sp>
+        <p:nvSpPr>
+          <p:cNvPr id="9" name="TextBox 8"/>
+          <p:cNvSpPr txBox="1"/>
+          <p:nvPr/>
+        </p:nvSpPr>
+        <p:spPr>
+          <a:xfrm>
+            <a:off x="6327648" y="2304288"/>
+            <a:ext cx="5120640" cy="3776472"/>
+          </a:xfrm>
+          <a:prstGeom prst="rect">
+            <a:avLst/>
+          </a:prstGeom>
+          <a:noFill/>
+        </p:spPr>
+        <p:txBody>
+          <a:bodyPr wrap="square">
+            <a:spAutoFit/>
+          </a:bodyPr>
+          <a:lstStyle/>
+          <a:p>
+            <a:pPr>
+              <a:spcAft>
+                <a:spcPts val="900"/>
+              </a:spcAft>
+              <a:defRPr sz="1600">
+                <a:solidFill>
+                  <a:srgbClr val="1C2D46"/>
+                </a:solidFill>
+                <a:latin typeface="Aptos"/>
+              </a:defRPr>
+            </a:pPr>
+            <a:r>
+              <a:t>Positioning: gentle, daily-use K-beauty skincare message.</a:t>
+            </a:r>
+          </a:p>
+          <a:p>
+            <a:pPr>
+              <a:spcAft>
+                <a:spcPts val="900"/>
+              </a:spcAft>
+              <a:defRPr sz="1600">
+                <a:solidFill>
+                  <a:srgbClr val="1C2D46"/>
+                </a:solidFill>
+                <a:latin typeface="Aptos"/>
+              </a:defRPr>
+            </a:pPr>
+            <a:r>
+              <a:t>Audience focus: sensitive/acne-aware Gen Z and Millennials.</a:t>
+            </a:r>
+          </a:p>
+          <a:p>
+            <a:pPr>
+              <a:spcAft>
+                <a:spcPts val="900"/>
+              </a:spcAft>
+              <a:defRPr sz="1600">
+                <a:solidFill>
+                  <a:srgbClr val="1C2D46"/>
+                </a:solidFill>
+                <a:latin typeface="Aptos"/>
+              </a:defRPr>
+            </a:pPr>
+            <a:r>
+              <a:t>Dataset source: videos_text_ready_combined.csv (n=67,283 videos)</a:t>
+            </a:r>
+          </a:p>
+          <a:p>
+            <a:pPr>
+              <a:spcAft>
+                <a:spcPts val="900"/>
+              </a:spcAft>
+              <a:defRPr sz="1600">
+                <a:solidFill>
+                  <a:srgbClr val="1C2D46"/>
+                </a:solidFill>
+                <a:latin typeface="Aptos"/>
+              </a:defRPr>
+            </a:pPr>
+            <a:r>
+              <a:t>sunscreen: 3,981 videos | 340 channels</a:t>
+            </a:r>
+          </a:p>
+          <a:p>
+            <a:pPr>
+              <a:spcAft>
+                <a:spcPts val="900"/>
+              </a:spcAft>
+              <a:defRPr sz="1600">
+                <a:solidFill>
+                  <a:srgbClr val="1C2D46"/>
+                </a:solidFill>
+                <a:latin typeface="Aptos"/>
+              </a:defRPr>
+            </a:pPr>
+            <a:r>
+              <a:t>spf: 3,850 videos | 344 channels</a:t>
+            </a:r>
+          </a:p>
+          <a:p>
+            <a:pPr>
+              <a:spcAft>
+                <a:spcPts val="900"/>
+              </a:spcAft>
+              <a:defRPr sz="1600">
+                <a:solidFill>
+                  <a:srgbClr val="1C2D46"/>
+                </a:solidFill>
+                <a:latin typeface="Aptos"/>
+              </a:defRPr>
+            </a:pPr>
+            <a:r>
+              <a:t>beauty of joseon: 286 videos | 69 channels</a:t>
+            </a:r>
+          </a:p>
+          <a:p>
+            <a:pPr>
+              <a:spcAft>
+                <a:spcPts val="900"/>
+              </a:spcAft>
+              <a:defRPr sz="1600">
+                <a:solidFill>
+                  <a:srgbClr val="1C2D46"/>
+                </a:solidFill>
+                <a:latin typeface="Aptos"/>
+              </a:defRPr>
+            </a:pPr>
+            <a:r>
+              <a:t>cerave: 747 videos | 118 channels</a:t>
+            </a:r>
+          </a:p>
+        </p:txBody>
+      </p:sp>
+      <p:sp>
+        <p:nvSpPr>
+          <p:cNvPr id="10" name="TextBox 9"/>
+          <p:cNvSpPr txBox="1"/>
+          <p:nvPr/>
+        </p:nvSpPr>
+        <p:spPr>
+          <a:xfrm>
+            <a:off x="502920" y="6428232"/>
+            <a:ext cx="10972800" cy="292608"/>
+          </a:xfrm>
+          <a:prstGeom prst="rect">
+            <a:avLst/>
+          </a:prstGeom>
+          <a:noFill/>
+        </p:spPr>
+        <p:txBody>
+          <a:bodyPr wrap="none">
+            <a:spAutoFit/>
+          </a:bodyPr>
+          <a:lstStyle/>
+          <a:p>
+            <a:pPr algn="r">
+              <a:defRPr sz="1000">
+                <a:solidFill>
+                  <a:srgbClr val="6E8098"/>
+                </a:solidFill>
+                <a:latin typeface="Aptos"/>
+              </a:defRPr>
+            </a:pPr>
+            <a:r>
+              <a:t>Brand choice is explicit, defensible, and data-backed</a:t>
+            </a:r>
+          </a:p>
+        </p:txBody>
+      </p:sp>
+    </p:spTree>
+  </p:cSld>
+  <p:clrMapOvr>
+    <a:masterClrMapping/>
+  </p:clrMapOvr>
+</p:sld>
+</file>
+
+<file path=ppt/slides/slide4.xml><?xml version="1.0" encoding="utf-8"?>
 <p:sld xmlns:a="http://schemas.openxmlformats.org/drawingml/2006/main" xmlns:p="http://schemas.openxmlformats.org/presentationml/2006/main" xmlns:r="http://schemas.openxmlformats.org/officeDocument/2006/relationships">
   <p:cSld>
     <p:spTree>
@@ -6523,662 +7350,6 @@
 </p:sld>
 </file>
 
-<file path=ppt/slides/slide4.xml><?xml version="1.0" encoding="utf-8"?>
-<p:sld xmlns:a="http://schemas.openxmlformats.org/drawingml/2006/main" xmlns:p="http://schemas.openxmlformats.org/presentationml/2006/main" xmlns:r="http://schemas.openxmlformats.org/officeDocument/2006/relationships">
-  <p:cSld>
-    <p:spTree>
-      <p:nvGrpSpPr>
-        <p:cNvPr id="1" name=""/>
-        <p:cNvGrpSpPr/>
-        <p:nvPr/>
-      </p:nvGrpSpPr>
-      <p:grpSpPr/>
-      <p:sp>
-        <p:nvSpPr>
-          <p:cNvPr id="2" name="TextBox 1"/>
-          <p:cNvSpPr txBox="1"/>
-          <p:nvPr/>
-        </p:nvSpPr>
-        <p:spPr>
-          <a:xfrm>
-            <a:off x="594360" y="320040"/>
-            <a:ext cx="11064240" cy="914400"/>
-          </a:xfrm>
-          <a:prstGeom prst="rect">
-            <a:avLst/>
-          </a:prstGeom>
-          <a:noFill/>
-        </p:spPr>
-        <p:txBody>
-          <a:bodyPr wrap="none">
-            <a:spAutoFit/>
-          </a:bodyPr>
-          <a:lstStyle/>
-          <a:p>
-            <a:pPr>
-              <a:defRPr sz="3400" b="1">
-                <a:solidFill>
-                  <a:srgbClr val="0F2C59"/>
-                </a:solidFill>
-                <a:latin typeface="Aptos Display"/>
-              </a:defRPr>
-            </a:pPr>
-            <a:r>
-              <a:t>Data Overview (BOJ Run)</a:t>
-            </a:r>
-          </a:p>
-        </p:txBody>
-      </p:sp>
-      <p:sp>
-        <p:nvSpPr>
-          <p:cNvPr id="3" name="Rectangle 2"/>
-          <p:cNvSpPr/>
-          <p:nvPr/>
-        </p:nvSpPr>
-        <p:spPr>
-          <a:xfrm>
-            <a:off x="566928" y="1783080"/>
-            <a:ext cx="2377440" cy="73152"/>
-          </a:xfrm>
-          <a:prstGeom prst="rect">
-            <a:avLst/>
-          </a:prstGeom>
-          <a:solidFill>
-            <a:srgbClr val="1A7DBC"/>
-          </a:solidFill>
-          <a:ln>
-            <a:noFill/>
-          </a:ln>
-        </p:spPr>
-        <p:style>
-          <a:lnRef idx="1">
-            <a:schemeClr val="accent1"/>
-          </a:lnRef>
-          <a:fillRef idx="3">
-            <a:schemeClr val="accent1"/>
-          </a:fillRef>
-          <a:effectRef idx="2">
-            <a:schemeClr val="accent1"/>
-          </a:effectRef>
-          <a:fontRef idx="minor">
-            <a:schemeClr val="lt1"/>
-          </a:fontRef>
-        </p:style>
-        <p:txBody>
-          <a:bodyPr rtlCol="0" anchor="ctr"/>
-          <a:lstStyle/>
-          <a:p>
-            <a:pPr algn="ctr"/>
-          </a:p>
-        </p:txBody>
-      </p:sp>
-      <p:sp>
-        <p:nvSpPr>
-          <p:cNvPr id="4" name="Rounded Rectangle 3"/>
-          <p:cNvSpPr/>
-          <p:nvPr/>
-        </p:nvSpPr>
-        <p:spPr>
-          <a:xfrm>
-            <a:off x="685800" y="2057400"/>
-            <a:ext cx="2697480" cy="1417320"/>
-          </a:xfrm>
-          <a:prstGeom prst="roundRect">
-            <a:avLst/>
-          </a:prstGeom>
-          <a:solidFill>
-            <a:srgbClr val="EBF5FF"/>
-          </a:solidFill>
-          <a:ln>
-            <a:solidFill>
-              <a:srgbClr val="BCD4EF"/>
-            </a:solidFill>
-          </a:ln>
-        </p:spPr>
-        <p:style>
-          <a:lnRef idx="1">
-            <a:schemeClr val="accent1"/>
-          </a:lnRef>
-          <a:fillRef idx="3">
-            <a:schemeClr val="accent1"/>
-          </a:fillRef>
-          <a:effectRef idx="2">
-            <a:schemeClr val="accent1"/>
-          </a:effectRef>
-          <a:fontRef idx="minor">
-            <a:schemeClr val="lt1"/>
-          </a:fontRef>
-        </p:style>
-        <p:txBody>
-          <a:bodyPr rtlCol="0" anchor="ctr"/>
-          <a:lstStyle/>
-          <a:p>
-            <a:pPr algn="ctr"/>
-          </a:p>
-        </p:txBody>
-      </p:sp>
-      <p:sp>
-        <p:nvSpPr>
-          <p:cNvPr id="5" name="TextBox 4"/>
-          <p:cNvSpPr txBox="1"/>
-          <p:nvPr/>
-        </p:nvSpPr>
-        <p:spPr>
-          <a:xfrm>
-            <a:off x="822960" y="2240280"/>
-            <a:ext cx="2423160" cy="512064"/>
-          </a:xfrm>
-          <a:prstGeom prst="rect">
-            <a:avLst/>
-          </a:prstGeom>
-          <a:noFill/>
-        </p:spPr>
-        <p:txBody>
-          <a:bodyPr wrap="none">
-            <a:spAutoFit/>
-          </a:bodyPr>
-          <a:lstStyle/>
-          <a:p>
-            <a:pPr>
-              <a:defRPr b="1" sz="2600">
-                <a:solidFill>
-                  <a:srgbClr val="1560A2"/>
-                </a:solidFill>
-                <a:latin typeface="Aptos Display"/>
-              </a:defRPr>
-            </a:pPr>
-            <a:r>
-              <a:t>42,750</a:t>
-            </a:r>
-          </a:p>
-        </p:txBody>
-      </p:sp>
-      <p:sp>
-        <p:nvSpPr>
-          <p:cNvPr id="6" name="TextBox 5"/>
-          <p:cNvSpPr txBox="1"/>
-          <p:nvPr/>
-        </p:nvSpPr>
-        <p:spPr>
-          <a:xfrm>
-            <a:off x="822960" y="2788920"/>
-            <a:ext cx="2423160" cy="365760"/>
-          </a:xfrm>
-          <a:prstGeom prst="rect">
-            <a:avLst/>
-          </a:prstGeom>
-          <a:noFill/>
-        </p:spPr>
-        <p:txBody>
-          <a:bodyPr wrap="none">
-            <a:spAutoFit/>
-          </a:bodyPr>
-          <a:lstStyle/>
-          <a:p>
-            <a:pPr>
-              <a:defRPr sz="1200">
-                <a:solidFill>
-                  <a:srgbClr val="3B577E"/>
-                </a:solidFill>
-                <a:latin typeface="Aptos"/>
-              </a:defRPr>
-            </a:pPr>
-            <a:r>
-              <a:t>Videos analyzed</a:t>
-            </a:r>
-          </a:p>
-        </p:txBody>
-      </p:sp>
-      <p:sp>
-        <p:nvSpPr>
-          <p:cNvPr id="7" name="Rounded Rectangle 6"/>
-          <p:cNvSpPr/>
-          <p:nvPr/>
-        </p:nvSpPr>
-        <p:spPr>
-          <a:xfrm>
-            <a:off x="3566160" y="2057400"/>
-            <a:ext cx="2697480" cy="1417320"/>
-          </a:xfrm>
-          <a:prstGeom prst="roundRect">
-            <a:avLst/>
-          </a:prstGeom>
-          <a:solidFill>
-            <a:srgbClr val="EBF5FF"/>
-          </a:solidFill>
-          <a:ln>
-            <a:solidFill>
-              <a:srgbClr val="BCD4EF"/>
-            </a:solidFill>
-          </a:ln>
-        </p:spPr>
-        <p:style>
-          <a:lnRef idx="1">
-            <a:schemeClr val="accent1"/>
-          </a:lnRef>
-          <a:fillRef idx="3">
-            <a:schemeClr val="accent1"/>
-          </a:fillRef>
-          <a:effectRef idx="2">
-            <a:schemeClr val="accent1"/>
-          </a:effectRef>
-          <a:fontRef idx="minor">
-            <a:schemeClr val="lt1"/>
-          </a:fontRef>
-        </p:style>
-        <p:txBody>
-          <a:bodyPr rtlCol="0" anchor="ctr"/>
-          <a:lstStyle/>
-          <a:p>
-            <a:pPr algn="ctr"/>
-          </a:p>
-        </p:txBody>
-      </p:sp>
-      <p:sp>
-        <p:nvSpPr>
-          <p:cNvPr id="8" name="TextBox 7"/>
-          <p:cNvSpPr txBox="1"/>
-          <p:nvPr/>
-        </p:nvSpPr>
-        <p:spPr>
-          <a:xfrm>
-            <a:off x="3703320" y="2240280"/>
-            <a:ext cx="2423160" cy="512064"/>
-          </a:xfrm>
-          <a:prstGeom prst="rect">
-            <a:avLst/>
-          </a:prstGeom>
-          <a:noFill/>
-        </p:spPr>
-        <p:txBody>
-          <a:bodyPr wrap="none">
-            <a:spAutoFit/>
-          </a:bodyPr>
-          <a:lstStyle/>
-          <a:p>
-            <a:pPr>
-              <a:defRPr b="1" sz="2600">
-                <a:solidFill>
-                  <a:srgbClr val="1560A2"/>
-                </a:solidFill>
-                <a:latin typeface="Aptos Display"/>
-              </a:defRPr>
-            </a:pPr>
-            <a:r>
-              <a:t>1,089</a:t>
-            </a:r>
-          </a:p>
-        </p:txBody>
-      </p:sp>
-      <p:sp>
-        <p:nvSpPr>
-          <p:cNvPr id="9" name="TextBox 8"/>
-          <p:cNvSpPr txBox="1"/>
-          <p:nvPr/>
-        </p:nvSpPr>
-        <p:spPr>
-          <a:xfrm>
-            <a:off x="3703320" y="2788920"/>
-            <a:ext cx="2423160" cy="365760"/>
-          </a:xfrm>
-          <a:prstGeom prst="rect">
-            <a:avLst/>
-          </a:prstGeom>
-          <a:noFill/>
-        </p:spPr>
-        <p:txBody>
-          <a:bodyPr wrap="none">
-            <a:spAutoFit/>
-          </a:bodyPr>
-          <a:lstStyle/>
-          <a:p>
-            <a:pPr>
-              <a:defRPr sz="1200">
-                <a:solidFill>
-                  <a:srgbClr val="3B577E"/>
-                </a:solidFill>
-                <a:latin typeface="Aptos"/>
-              </a:defRPr>
-            </a:pPr>
-            <a:r>
-              <a:t>Channels scored</a:t>
-            </a:r>
-          </a:p>
-        </p:txBody>
-      </p:sp>
-      <p:sp>
-        <p:nvSpPr>
-          <p:cNvPr id="10" name="Rounded Rectangle 9"/>
-          <p:cNvSpPr/>
-          <p:nvPr/>
-        </p:nvSpPr>
-        <p:spPr>
-          <a:xfrm>
-            <a:off x="6446520" y="2057400"/>
-            <a:ext cx="2697480" cy="1417320"/>
-          </a:xfrm>
-          <a:prstGeom prst="roundRect">
-            <a:avLst/>
-          </a:prstGeom>
-          <a:solidFill>
-            <a:srgbClr val="EBF5FF"/>
-          </a:solidFill>
-          <a:ln>
-            <a:solidFill>
-              <a:srgbClr val="BCD4EF"/>
-            </a:solidFill>
-          </a:ln>
-        </p:spPr>
-        <p:style>
-          <a:lnRef idx="1">
-            <a:schemeClr val="accent1"/>
-          </a:lnRef>
-          <a:fillRef idx="3">
-            <a:schemeClr val="accent1"/>
-          </a:fillRef>
-          <a:effectRef idx="2">
-            <a:schemeClr val="accent1"/>
-          </a:effectRef>
-          <a:fontRef idx="minor">
-            <a:schemeClr val="lt1"/>
-          </a:fontRef>
-        </p:style>
-        <p:txBody>
-          <a:bodyPr rtlCol="0" anchor="ctr"/>
-          <a:lstStyle/>
-          <a:p>
-            <a:pPr algn="ctr"/>
-          </a:p>
-        </p:txBody>
-      </p:sp>
-      <p:sp>
-        <p:nvSpPr>
-          <p:cNvPr id="11" name="TextBox 10"/>
-          <p:cNvSpPr txBox="1"/>
-          <p:nvPr/>
-        </p:nvSpPr>
-        <p:spPr>
-          <a:xfrm>
-            <a:off x="6583680" y="2240280"/>
-            <a:ext cx="2423160" cy="512064"/>
-          </a:xfrm>
-          <a:prstGeom prst="rect">
-            <a:avLst/>
-          </a:prstGeom>
-          <a:noFill/>
-        </p:spPr>
-        <p:txBody>
-          <a:bodyPr wrap="none">
-            <a:spAutoFit/>
-          </a:bodyPr>
-          <a:lstStyle/>
-          <a:p>
-            <a:pPr>
-              <a:defRPr b="1" sz="2600">
-                <a:solidFill>
-                  <a:srgbClr val="1560A2"/>
-                </a:solidFill>
-                <a:latin typeface="Aptos Display"/>
-              </a:defRPr>
-            </a:pPr>
-            <a:r>
-              <a:t>Top-10</a:t>
-            </a:r>
-          </a:p>
-        </p:txBody>
-      </p:sp>
-      <p:sp>
-        <p:nvSpPr>
-          <p:cNvPr id="12" name="TextBox 11"/>
-          <p:cNvSpPr txBox="1"/>
-          <p:nvPr/>
-        </p:nvSpPr>
-        <p:spPr>
-          <a:xfrm>
-            <a:off x="6583680" y="2788920"/>
-            <a:ext cx="2423160" cy="365760"/>
-          </a:xfrm>
-          <a:prstGeom prst="rect">
-            <a:avLst/>
-          </a:prstGeom>
-          <a:noFill/>
-        </p:spPr>
-        <p:txBody>
-          <a:bodyPr wrap="none">
-            <a:spAutoFit/>
-          </a:bodyPr>
-          <a:lstStyle/>
-          <a:p>
-            <a:pPr>
-              <a:defRPr sz="1200">
-                <a:solidFill>
-                  <a:srgbClr val="3B577E"/>
-                </a:solidFill>
-                <a:latin typeface="Aptos"/>
-              </a:defRPr>
-            </a:pPr>
-            <a:r>
-              <a:t>Default recommendations</a:t>
-            </a:r>
-          </a:p>
-        </p:txBody>
-      </p:sp>
-      <p:sp>
-        <p:nvSpPr>
-          <p:cNvPr id="13" name="Rounded Rectangle 12"/>
-          <p:cNvSpPr/>
-          <p:nvPr/>
-        </p:nvSpPr>
-        <p:spPr>
-          <a:xfrm>
-            <a:off x="9326880" y="2057400"/>
-            <a:ext cx="2697480" cy="1417320"/>
-          </a:xfrm>
-          <a:prstGeom prst="roundRect">
-            <a:avLst/>
-          </a:prstGeom>
-          <a:solidFill>
-            <a:srgbClr val="EBF5FF"/>
-          </a:solidFill>
-          <a:ln>
-            <a:solidFill>
-              <a:srgbClr val="BCD4EF"/>
-            </a:solidFill>
-          </a:ln>
-        </p:spPr>
-        <p:style>
-          <a:lnRef idx="1">
-            <a:schemeClr val="accent1"/>
-          </a:lnRef>
-          <a:fillRef idx="3">
-            <a:schemeClr val="accent1"/>
-          </a:fillRef>
-          <a:effectRef idx="2">
-            <a:schemeClr val="accent1"/>
-          </a:effectRef>
-          <a:fontRef idx="minor">
-            <a:schemeClr val="lt1"/>
-          </a:fontRef>
-        </p:style>
-        <p:txBody>
-          <a:bodyPr rtlCol="0" anchor="ctr"/>
-          <a:lstStyle/>
-          <a:p>
-            <a:pPr algn="ctr"/>
-          </a:p>
-        </p:txBody>
-      </p:sp>
-      <p:sp>
-        <p:nvSpPr>
-          <p:cNvPr id="14" name="TextBox 13"/>
-          <p:cNvSpPr txBox="1"/>
-          <p:nvPr/>
-        </p:nvSpPr>
-        <p:spPr>
-          <a:xfrm>
-            <a:off x="9464040" y="2240280"/>
-            <a:ext cx="2423160" cy="512064"/>
-          </a:xfrm>
-          <a:prstGeom prst="rect">
-            <a:avLst/>
-          </a:prstGeom>
-          <a:noFill/>
-        </p:spPr>
-        <p:txBody>
-          <a:bodyPr wrap="none">
-            <a:spAutoFit/>
-          </a:bodyPr>
-          <a:lstStyle/>
-          <a:p>
-            <a:pPr>
-              <a:defRPr b="1" sz="2600">
-                <a:solidFill>
-                  <a:srgbClr val="1560A2"/>
-                </a:solidFill>
-                <a:latin typeface="Aptos Display"/>
-              </a:defRPr>
-            </a:pPr>
-            <a:r>
-              <a:t>6</a:t>
-            </a:r>
-          </a:p>
-        </p:txBody>
-      </p:sp>
-      <p:sp>
-        <p:nvSpPr>
-          <p:cNvPr id="15" name="TextBox 14"/>
-          <p:cNvSpPr txBox="1"/>
-          <p:nvPr/>
-        </p:nvSpPr>
-        <p:spPr>
-          <a:xfrm>
-            <a:off x="9464040" y="2788920"/>
-            <a:ext cx="2423160" cy="365760"/>
-          </a:xfrm>
-          <a:prstGeom prst="rect">
-            <a:avLst/>
-          </a:prstGeom>
-          <a:noFill/>
-        </p:spPr>
-        <p:txBody>
-          <a:bodyPr wrap="none">
-            <a:spAutoFit/>
-          </a:bodyPr>
-          <a:lstStyle/>
-          <a:p>
-            <a:pPr>
-              <a:defRPr sz="1200">
-                <a:solidFill>
-                  <a:srgbClr val="3B577E"/>
-                </a:solidFill>
-                <a:latin typeface="Aptos"/>
-              </a:defRPr>
-            </a:pPr>
-            <a:r>
-              <a:t>Non-micro communities</a:t>
-            </a:r>
-          </a:p>
-        </p:txBody>
-      </p:sp>
-      <p:sp>
-        <p:nvSpPr>
-          <p:cNvPr id="16" name="TextBox 15"/>
-          <p:cNvSpPr txBox="1"/>
-          <p:nvPr/>
-        </p:nvSpPr>
-        <p:spPr>
-          <a:xfrm>
-            <a:off x="731520" y="3840480"/>
-            <a:ext cx="10972800" cy="1920240"/>
-          </a:xfrm>
-          <a:prstGeom prst="rect">
-            <a:avLst/>
-          </a:prstGeom>
-          <a:noFill/>
-        </p:spPr>
-        <p:txBody>
-          <a:bodyPr wrap="square">
-            <a:spAutoFit/>
-          </a:bodyPr>
-          <a:lstStyle/>
-          <a:p>
-            <a:pPr>
-              <a:spcAft>
-                <a:spcPts val="900"/>
-              </a:spcAft>
-              <a:defRPr sz="1500">
-                <a:solidFill>
-                  <a:srgbClr val="1C2D46"/>
-                </a:solidFill>
-                <a:latin typeface="Aptos"/>
-              </a:defRPr>
-            </a:pPr>
-            <a:r>
-              <a:t>Input files: videos_text_ready_combined.csv, comments_raw_combined.csv, master_prd_slim_combined.csv</a:t>
-            </a:r>
-          </a:p>
-          <a:p>
-            <a:pPr>
-              <a:spcAft>
-                <a:spcPts val="900"/>
-              </a:spcAft>
-              <a:defRPr sz="1500">
-                <a:solidFill>
-                  <a:srgbClr val="1C2D46"/>
-                </a:solidFill>
-                <a:latin typeface="Aptos"/>
-              </a:defRPr>
-            </a:pPr>
-            <a:r>
-              <a:t>Campaign input: BOJ SPF + Glow Serum, U.S. market, sensitive-skin audience, $50,000 budget</a:t>
-            </a:r>
-          </a:p>
-        </p:txBody>
-      </p:sp>
-      <p:sp>
-        <p:nvSpPr>
-          <p:cNvPr id="17" name="TextBox 16"/>
-          <p:cNvSpPr txBox="1"/>
-          <p:nvPr/>
-        </p:nvSpPr>
-        <p:spPr>
-          <a:xfrm>
-            <a:off x="502920" y="6428232"/>
-            <a:ext cx="10972800" cy="292608"/>
-          </a:xfrm>
-          <a:prstGeom prst="rect">
-            <a:avLst/>
-          </a:prstGeom>
-          <a:noFill/>
-        </p:spPr>
-        <p:txBody>
-          <a:bodyPr wrap="none">
-            <a:spAutoFit/>
-          </a:bodyPr>
-          <a:lstStyle/>
-          <a:p>
-            <a:pPr algn="r">
-              <a:defRPr sz="1000">
-                <a:solidFill>
-                  <a:srgbClr val="6E8098"/>
-                </a:solidFill>
-                <a:latin typeface="Aptos"/>
-              </a:defRPr>
-            </a:pPr>
-            <a:r>
-              <a:t>Data-driven prototype with fixed reproducible input</a:t>
-            </a:r>
-          </a:p>
-        </p:txBody>
-      </p:sp>
-    </p:spTree>
-  </p:cSld>
-  <p:clrMapOvr>
-    <a:masterClrMapping/>
-  </p:clrMapOvr>
-</p:sld>
-</file>
-
 <file path=ppt/slides/slide5.xml><?xml version="1.0" encoding="utf-8"?>
 <p:sld xmlns:a="http://schemas.openxmlformats.org/drawingml/2006/main" xmlns:p="http://schemas.openxmlformats.org/presentationml/2006/main" xmlns:r="http://schemas.openxmlformats.org/officeDocument/2006/relationships">
   <p:cSld>
@@ -7220,7 +7391,7 @@
               </a:defRPr>
             </a:pPr>
             <a:r>
-              <a:t>Method Pipeline</a:t>
+              <a:t>Data Overview (BOJ Run)</a:t>
             </a:r>
           </a:p>
         </p:txBody>
@@ -7270,14 +7441,482 @@
       </p:sp>
       <p:sp>
         <p:nvSpPr>
-          <p:cNvPr id="4" name="TextBox 3"/>
+          <p:cNvPr id="4" name="Rounded Rectangle 3"/>
+          <p:cNvSpPr/>
+          <p:nvPr/>
+        </p:nvSpPr>
+        <p:spPr>
+          <a:xfrm>
+            <a:off x="685800" y="2057400"/>
+            <a:ext cx="2697480" cy="1417320"/>
+          </a:xfrm>
+          <a:prstGeom prst="roundRect">
+            <a:avLst/>
+          </a:prstGeom>
+          <a:solidFill>
+            <a:srgbClr val="EBF5FF"/>
+          </a:solidFill>
+          <a:ln>
+            <a:solidFill>
+              <a:srgbClr val="BCD4EF"/>
+            </a:solidFill>
+          </a:ln>
+        </p:spPr>
+        <p:style>
+          <a:lnRef idx="1">
+            <a:schemeClr val="accent1"/>
+          </a:lnRef>
+          <a:fillRef idx="3">
+            <a:schemeClr val="accent1"/>
+          </a:fillRef>
+          <a:effectRef idx="2">
+            <a:schemeClr val="accent1"/>
+          </a:effectRef>
+          <a:fontRef idx="minor">
+            <a:schemeClr val="lt1"/>
+          </a:fontRef>
+        </p:style>
+        <p:txBody>
+          <a:bodyPr rtlCol="0" anchor="ctr"/>
+          <a:lstStyle/>
+          <a:p>
+            <a:pPr algn="ctr"/>
+          </a:p>
+        </p:txBody>
+      </p:sp>
+      <p:sp>
+        <p:nvSpPr>
+          <p:cNvPr id="5" name="TextBox 4"/>
           <p:cNvSpPr txBox="1"/>
           <p:nvPr/>
         </p:nvSpPr>
         <p:spPr>
           <a:xfrm>
-            <a:off x="685800" y="1828800"/>
-            <a:ext cx="10972800" cy="4480560"/>
+            <a:off x="822960" y="2240280"/>
+            <a:ext cx="2423160" cy="512064"/>
+          </a:xfrm>
+          <a:prstGeom prst="rect">
+            <a:avLst/>
+          </a:prstGeom>
+          <a:noFill/>
+        </p:spPr>
+        <p:txBody>
+          <a:bodyPr wrap="none">
+            <a:spAutoFit/>
+          </a:bodyPr>
+          <a:lstStyle/>
+          <a:p>
+            <a:pPr>
+              <a:defRPr b="1" sz="2600">
+                <a:solidFill>
+                  <a:srgbClr val="1560A2"/>
+                </a:solidFill>
+                <a:latin typeface="Aptos Display"/>
+              </a:defRPr>
+            </a:pPr>
+            <a:r>
+              <a:t>42,750</a:t>
+            </a:r>
+          </a:p>
+        </p:txBody>
+      </p:sp>
+      <p:sp>
+        <p:nvSpPr>
+          <p:cNvPr id="6" name="TextBox 5"/>
+          <p:cNvSpPr txBox="1"/>
+          <p:nvPr/>
+        </p:nvSpPr>
+        <p:spPr>
+          <a:xfrm>
+            <a:off x="822960" y="2788920"/>
+            <a:ext cx="2423160" cy="365760"/>
+          </a:xfrm>
+          <a:prstGeom prst="rect">
+            <a:avLst/>
+          </a:prstGeom>
+          <a:noFill/>
+        </p:spPr>
+        <p:txBody>
+          <a:bodyPr wrap="none">
+            <a:spAutoFit/>
+          </a:bodyPr>
+          <a:lstStyle/>
+          <a:p>
+            <a:pPr>
+              <a:defRPr sz="1200">
+                <a:solidFill>
+                  <a:srgbClr val="3B577E"/>
+                </a:solidFill>
+                <a:latin typeface="Aptos"/>
+              </a:defRPr>
+            </a:pPr>
+            <a:r>
+              <a:t>Videos analyzed</a:t>
+            </a:r>
+          </a:p>
+        </p:txBody>
+      </p:sp>
+      <p:sp>
+        <p:nvSpPr>
+          <p:cNvPr id="7" name="Rounded Rectangle 6"/>
+          <p:cNvSpPr/>
+          <p:nvPr/>
+        </p:nvSpPr>
+        <p:spPr>
+          <a:xfrm>
+            <a:off x="3566160" y="2057400"/>
+            <a:ext cx="2697480" cy="1417320"/>
+          </a:xfrm>
+          <a:prstGeom prst="roundRect">
+            <a:avLst/>
+          </a:prstGeom>
+          <a:solidFill>
+            <a:srgbClr val="EBF5FF"/>
+          </a:solidFill>
+          <a:ln>
+            <a:solidFill>
+              <a:srgbClr val="BCD4EF"/>
+            </a:solidFill>
+          </a:ln>
+        </p:spPr>
+        <p:style>
+          <a:lnRef idx="1">
+            <a:schemeClr val="accent1"/>
+          </a:lnRef>
+          <a:fillRef idx="3">
+            <a:schemeClr val="accent1"/>
+          </a:fillRef>
+          <a:effectRef idx="2">
+            <a:schemeClr val="accent1"/>
+          </a:effectRef>
+          <a:fontRef idx="minor">
+            <a:schemeClr val="lt1"/>
+          </a:fontRef>
+        </p:style>
+        <p:txBody>
+          <a:bodyPr rtlCol="0" anchor="ctr"/>
+          <a:lstStyle/>
+          <a:p>
+            <a:pPr algn="ctr"/>
+          </a:p>
+        </p:txBody>
+      </p:sp>
+      <p:sp>
+        <p:nvSpPr>
+          <p:cNvPr id="8" name="TextBox 7"/>
+          <p:cNvSpPr txBox="1"/>
+          <p:nvPr/>
+        </p:nvSpPr>
+        <p:spPr>
+          <a:xfrm>
+            <a:off x="3703320" y="2240280"/>
+            <a:ext cx="2423160" cy="512064"/>
+          </a:xfrm>
+          <a:prstGeom prst="rect">
+            <a:avLst/>
+          </a:prstGeom>
+          <a:noFill/>
+        </p:spPr>
+        <p:txBody>
+          <a:bodyPr wrap="none">
+            <a:spAutoFit/>
+          </a:bodyPr>
+          <a:lstStyle/>
+          <a:p>
+            <a:pPr>
+              <a:defRPr b="1" sz="2600">
+                <a:solidFill>
+                  <a:srgbClr val="1560A2"/>
+                </a:solidFill>
+                <a:latin typeface="Aptos Display"/>
+              </a:defRPr>
+            </a:pPr>
+            <a:r>
+              <a:t>1,089</a:t>
+            </a:r>
+          </a:p>
+        </p:txBody>
+      </p:sp>
+      <p:sp>
+        <p:nvSpPr>
+          <p:cNvPr id="9" name="TextBox 8"/>
+          <p:cNvSpPr txBox="1"/>
+          <p:nvPr/>
+        </p:nvSpPr>
+        <p:spPr>
+          <a:xfrm>
+            <a:off x="3703320" y="2788920"/>
+            <a:ext cx="2423160" cy="365760"/>
+          </a:xfrm>
+          <a:prstGeom prst="rect">
+            <a:avLst/>
+          </a:prstGeom>
+          <a:noFill/>
+        </p:spPr>
+        <p:txBody>
+          <a:bodyPr wrap="none">
+            <a:spAutoFit/>
+          </a:bodyPr>
+          <a:lstStyle/>
+          <a:p>
+            <a:pPr>
+              <a:defRPr sz="1200">
+                <a:solidFill>
+                  <a:srgbClr val="3B577E"/>
+                </a:solidFill>
+                <a:latin typeface="Aptos"/>
+              </a:defRPr>
+            </a:pPr>
+            <a:r>
+              <a:t>Channels scored</a:t>
+            </a:r>
+          </a:p>
+        </p:txBody>
+      </p:sp>
+      <p:sp>
+        <p:nvSpPr>
+          <p:cNvPr id="10" name="Rounded Rectangle 9"/>
+          <p:cNvSpPr/>
+          <p:nvPr/>
+        </p:nvSpPr>
+        <p:spPr>
+          <a:xfrm>
+            <a:off x="6446520" y="2057400"/>
+            <a:ext cx="2697480" cy="1417320"/>
+          </a:xfrm>
+          <a:prstGeom prst="roundRect">
+            <a:avLst/>
+          </a:prstGeom>
+          <a:solidFill>
+            <a:srgbClr val="EBF5FF"/>
+          </a:solidFill>
+          <a:ln>
+            <a:solidFill>
+              <a:srgbClr val="BCD4EF"/>
+            </a:solidFill>
+          </a:ln>
+        </p:spPr>
+        <p:style>
+          <a:lnRef idx="1">
+            <a:schemeClr val="accent1"/>
+          </a:lnRef>
+          <a:fillRef idx="3">
+            <a:schemeClr val="accent1"/>
+          </a:fillRef>
+          <a:effectRef idx="2">
+            <a:schemeClr val="accent1"/>
+          </a:effectRef>
+          <a:fontRef idx="minor">
+            <a:schemeClr val="lt1"/>
+          </a:fontRef>
+        </p:style>
+        <p:txBody>
+          <a:bodyPr rtlCol="0" anchor="ctr"/>
+          <a:lstStyle/>
+          <a:p>
+            <a:pPr algn="ctr"/>
+          </a:p>
+        </p:txBody>
+      </p:sp>
+      <p:sp>
+        <p:nvSpPr>
+          <p:cNvPr id="11" name="TextBox 10"/>
+          <p:cNvSpPr txBox="1"/>
+          <p:nvPr/>
+        </p:nvSpPr>
+        <p:spPr>
+          <a:xfrm>
+            <a:off x="6583680" y="2240280"/>
+            <a:ext cx="2423160" cy="512064"/>
+          </a:xfrm>
+          <a:prstGeom prst="rect">
+            <a:avLst/>
+          </a:prstGeom>
+          <a:noFill/>
+        </p:spPr>
+        <p:txBody>
+          <a:bodyPr wrap="none">
+            <a:spAutoFit/>
+          </a:bodyPr>
+          <a:lstStyle/>
+          <a:p>
+            <a:pPr>
+              <a:defRPr b="1" sz="2600">
+                <a:solidFill>
+                  <a:srgbClr val="1560A2"/>
+                </a:solidFill>
+                <a:latin typeface="Aptos Display"/>
+              </a:defRPr>
+            </a:pPr>
+            <a:r>
+              <a:t>Top-10</a:t>
+            </a:r>
+          </a:p>
+        </p:txBody>
+      </p:sp>
+      <p:sp>
+        <p:nvSpPr>
+          <p:cNvPr id="12" name="TextBox 11"/>
+          <p:cNvSpPr txBox="1"/>
+          <p:nvPr/>
+        </p:nvSpPr>
+        <p:spPr>
+          <a:xfrm>
+            <a:off x="6583680" y="2788920"/>
+            <a:ext cx="2423160" cy="365760"/>
+          </a:xfrm>
+          <a:prstGeom prst="rect">
+            <a:avLst/>
+          </a:prstGeom>
+          <a:noFill/>
+        </p:spPr>
+        <p:txBody>
+          <a:bodyPr wrap="none">
+            <a:spAutoFit/>
+          </a:bodyPr>
+          <a:lstStyle/>
+          <a:p>
+            <a:pPr>
+              <a:defRPr sz="1200">
+                <a:solidFill>
+                  <a:srgbClr val="3B577E"/>
+                </a:solidFill>
+                <a:latin typeface="Aptos"/>
+              </a:defRPr>
+            </a:pPr>
+            <a:r>
+              <a:t>Default recommendations</a:t>
+            </a:r>
+          </a:p>
+        </p:txBody>
+      </p:sp>
+      <p:sp>
+        <p:nvSpPr>
+          <p:cNvPr id="13" name="Rounded Rectangle 12"/>
+          <p:cNvSpPr/>
+          <p:nvPr/>
+        </p:nvSpPr>
+        <p:spPr>
+          <a:xfrm>
+            <a:off x="9326880" y="2057400"/>
+            <a:ext cx="2697480" cy="1417320"/>
+          </a:xfrm>
+          <a:prstGeom prst="roundRect">
+            <a:avLst/>
+          </a:prstGeom>
+          <a:solidFill>
+            <a:srgbClr val="EBF5FF"/>
+          </a:solidFill>
+          <a:ln>
+            <a:solidFill>
+              <a:srgbClr val="BCD4EF"/>
+            </a:solidFill>
+          </a:ln>
+        </p:spPr>
+        <p:style>
+          <a:lnRef idx="1">
+            <a:schemeClr val="accent1"/>
+          </a:lnRef>
+          <a:fillRef idx="3">
+            <a:schemeClr val="accent1"/>
+          </a:fillRef>
+          <a:effectRef idx="2">
+            <a:schemeClr val="accent1"/>
+          </a:effectRef>
+          <a:fontRef idx="minor">
+            <a:schemeClr val="lt1"/>
+          </a:fontRef>
+        </p:style>
+        <p:txBody>
+          <a:bodyPr rtlCol="0" anchor="ctr"/>
+          <a:lstStyle/>
+          <a:p>
+            <a:pPr algn="ctr"/>
+          </a:p>
+        </p:txBody>
+      </p:sp>
+      <p:sp>
+        <p:nvSpPr>
+          <p:cNvPr id="14" name="TextBox 13"/>
+          <p:cNvSpPr txBox="1"/>
+          <p:nvPr/>
+        </p:nvSpPr>
+        <p:spPr>
+          <a:xfrm>
+            <a:off x="9464040" y="2240280"/>
+            <a:ext cx="2423160" cy="512064"/>
+          </a:xfrm>
+          <a:prstGeom prst="rect">
+            <a:avLst/>
+          </a:prstGeom>
+          <a:noFill/>
+        </p:spPr>
+        <p:txBody>
+          <a:bodyPr wrap="none">
+            <a:spAutoFit/>
+          </a:bodyPr>
+          <a:lstStyle/>
+          <a:p>
+            <a:pPr>
+              <a:defRPr b="1" sz="2600">
+                <a:solidFill>
+                  <a:srgbClr val="1560A2"/>
+                </a:solidFill>
+                <a:latin typeface="Aptos Display"/>
+              </a:defRPr>
+            </a:pPr>
+            <a:r>
+              <a:t>6</a:t>
+            </a:r>
+          </a:p>
+        </p:txBody>
+      </p:sp>
+      <p:sp>
+        <p:nvSpPr>
+          <p:cNvPr id="15" name="TextBox 14"/>
+          <p:cNvSpPr txBox="1"/>
+          <p:nvPr/>
+        </p:nvSpPr>
+        <p:spPr>
+          <a:xfrm>
+            <a:off x="9464040" y="2788920"/>
+            <a:ext cx="2423160" cy="365760"/>
+          </a:xfrm>
+          <a:prstGeom prst="rect">
+            <a:avLst/>
+          </a:prstGeom>
+          <a:noFill/>
+        </p:spPr>
+        <p:txBody>
+          <a:bodyPr wrap="none">
+            <a:spAutoFit/>
+          </a:bodyPr>
+          <a:lstStyle/>
+          <a:p>
+            <a:pPr>
+              <a:defRPr sz="1200">
+                <a:solidFill>
+                  <a:srgbClr val="3B577E"/>
+                </a:solidFill>
+                <a:latin typeface="Aptos"/>
+              </a:defRPr>
+            </a:pPr>
+            <a:r>
+              <a:t>Non-micro communities</a:t>
+            </a:r>
+          </a:p>
+        </p:txBody>
+      </p:sp>
+      <p:sp>
+        <p:nvSpPr>
+          <p:cNvPr id="16" name="TextBox 15"/>
+          <p:cNvSpPr txBox="1"/>
+          <p:nvPr/>
+        </p:nvSpPr>
+        <p:spPr>
+          <a:xfrm>
+            <a:off x="731520" y="3840480"/>
+            <a:ext cx="10972800" cy="1920240"/>
           </a:xfrm>
           <a:prstGeom prst="rect">
             <a:avLst/>
@@ -7294,7 +7933,7 @@
               <a:spcAft>
                 <a:spcPts val="900"/>
               </a:spcAft>
-              <a:defRPr sz="1900">
+              <a:defRPr sz="1500">
                 <a:solidFill>
                   <a:srgbClr val="1C2D46"/>
                 </a:solidFill>
@@ -7302,7 +7941,7 @@
               </a:defRPr>
             </a:pPr>
             <a:r>
-              <a:t>1) Data cleaning + beauty/noise filter</a:t>
+              <a:t>Input files: videos_text_ready_combined.csv, comments_raw_combined.csv, master_prd_slim_combined.csv</a:t>
             </a:r>
           </a:p>
           <a:p>
@@ -7310,7 +7949,7 @@
               <a:spcAft>
                 <a:spcPts val="900"/>
               </a:spcAft>
-              <a:defRPr sz="1900">
+              <a:defRPr sz="1500">
                 <a:solidFill>
                   <a:srgbClr val="1C2D46"/>
                 </a:solidFill>
@@ -7318,94 +7957,14 @@
               </a:defRPr>
             </a:pPr>
             <a:r>
-              <a:t>2) Channel aggregation and text profile generation</a:t>
-            </a:r>
-          </a:p>
-          <a:p>
-            <a:pPr>
-              <a:spcAft>
-                <a:spcPts val="900"/>
-              </a:spcAft>
-              <a:defRPr sz="1900">
-                <a:solidFill>
-                  <a:srgbClr val="1C2D46"/>
-                </a:solidFill>
-                <a:latin typeface="Aptos"/>
-              </a:defRPr>
-            </a:pPr>
-            <a:r>
-              <a:t>3) Network scoring (centrality + community detection)</a:t>
-            </a:r>
-          </a:p>
-          <a:p>
-            <a:pPr>
-              <a:spcAft>
-                <a:spcPts val="900"/>
-              </a:spcAft>
-              <a:defRPr sz="1900">
-                <a:solidFill>
-                  <a:srgbClr val="1C2D46"/>
-                </a:solidFill>
-                <a:latin typeface="Aptos"/>
-              </a:defRPr>
-            </a:pPr>
-            <a:r>
-              <a:t>4) TF-IDF relevance + semantic/tone enrichment</a:t>
-            </a:r>
-          </a:p>
-          <a:p>
-            <a:pPr>
-              <a:spcAft>
-                <a:spcPts val="900"/>
-              </a:spcAft>
-              <a:defRPr sz="1900">
-                <a:solidFill>
-                  <a:srgbClr val="1C2D46"/>
-                </a:solidFill>
-                <a:latin typeface="Aptos"/>
-              </a:defRPr>
-            </a:pPr>
-            <a:r>
-              <a:t>5) Evidence guardrail + diversity-aware ranking</a:t>
-            </a:r>
-          </a:p>
-          <a:p>
-            <a:pPr>
-              <a:spcAft>
-                <a:spcPts val="900"/>
-              </a:spcAft>
-              <a:defRPr sz="1900">
-                <a:solidFill>
-                  <a:srgbClr val="1C2D46"/>
-                </a:solidFill>
-                <a:latin typeface="Aptos"/>
-              </a:defRPr>
-            </a:pPr>
-            <a:r>
-              <a:t>6) ML benchmark (Linear/LASSO/Ridge/CART/RF/LightGBM, GroupKFold 5-fold)</a:t>
-            </a:r>
-          </a:p>
-          <a:p>
-            <a:pPr>
-              <a:spcAft>
-                <a:spcPts val="900"/>
-              </a:spcAft>
-              <a:defRPr sz="1900">
-                <a:solidFill>
-                  <a:srgbClr val="1C2D46"/>
-                </a:solidFill>
-                <a:latin typeface="Aptos"/>
-              </a:defRPr>
-            </a:pPr>
-            <a:r>
-              <a:t>7) ROI simulation + strategy generation + executive memo</a:t>
-            </a:r>
-          </a:p>
-        </p:txBody>
-      </p:sp>
-      <p:sp>
-        <p:nvSpPr>
-          <p:cNvPr id="5" name="TextBox 4"/>
+              <a:t>Campaign input: BOJ SPF + Glow Serum, U.S. market, sensitive-skin audience, $50,000 budget</a:t>
+            </a:r>
+          </a:p>
+        </p:txBody>
+      </p:sp>
+      <p:sp>
+        <p:nvSpPr>
+          <p:cNvPr id="17" name="TextBox 16"/>
           <p:cNvSpPr txBox="1"/>
           <p:nvPr/>
         </p:nvSpPr>
@@ -7434,7 +7993,7 @@
               </a:defRPr>
             </a:pPr>
             <a:r>
-              <a:t>Rubric 3: Technical aspects and method choice</a:t>
+              <a:t>Data-driven prototype with fixed reproducible input</a:t>
             </a:r>
           </a:p>
         </p:txBody>
@@ -7488,7 +8047,7 @@
               </a:defRPr>
             </a:pPr>
             <a:r>
-              <a:t>Model Evaluation Results</a:t>
+              <a:t>Method Pipeline</a:t>
             </a:r>
           </a:p>
         </p:txBody>
@@ -7536,85 +8095,151 @@
           </a:p>
         </p:txBody>
       </p:sp>
-      <p:pic>
-        <p:nvPicPr>
-          <p:cNvPr id="4" name="Picture 3" descr="model_benchmark_rmse.png"/>
-          <p:cNvPicPr>
-            <a:picLocks noChangeAspect="1"/>
-          </p:cNvPicPr>
-          <p:nvPr/>
-        </p:nvPicPr>
-        <p:blipFill>
-          <a:blip r:embed="rId2"/>
-          <a:stretch>
-            <a:fillRect/>
-          </a:stretch>
-        </p:blipFill>
-        <p:spPr>
-          <a:xfrm>
-            <a:off x="731520" y="1828800"/>
-            <a:ext cx="8237220" cy="4297680"/>
-          </a:xfrm>
-          <a:prstGeom prst="rect">
-            <a:avLst/>
-          </a:prstGeom>
-        </p:spPr>
-      </p:pic>
-      <p:sp>
-        <p:nvSpPr>
-          <p:cNvPr id="5" name="Rounded Rectangle 4"/>
-          <p:cNvSpPr/>
-          <p:nvPr/>
-        </p:nvSpPr>
-        <p:spPr>
-          <a:xfrm>
-            <a:off x="7315200" y="1828800"/>
-            <a:ext cx="4114800" cy="4297680"/>
-          </a:xfrm>
-          <a:prstGeom prst="roundRect">
-            <a:avLst/>
-          </a:prstGeom>
-          <a:solidFill>
-            <a:srgbClr val="F2F7FC"/>
-          </a:solidFill>
-          <a:ln w="15875">
-            <a:solidFill>
-              <a:srgbClr val="CDDCEE"/>
-            </a:solidFill>
-          </a:ln>
-        </p:spPr>
-        <p:style>
-          <a:lnRef idx="1">
-            <a:schemeClr val="accent1"/>
-          </a:lnRef>
-          <a:fillRef idx="3">
-            <a:schemeClr val="accent1"/>
-          </a:fillRef>
-          <a:effectRef idx="2">
-            <a:schemeClr val="accent1"/>
-          </a:effectRef>
-          <a:fontRef idx="minor">
-            <a:schemeClr val="lt1"/>
-          </a:fontRef>
-        </p:style>
-        <p:txBody>
-          <a:bodyPr rtlCol="0" anchor="ctr"/>
-          <a:lstStyle/>
-          <a:p>
-            <a:pPr algn="ctr"/>
-          </a:p>
-        </p:txBody>
-      </p:sp>
-      <p:sp>
-        <p:nvSpPr>
-          <p:cNvPr id="6" name="TextBox 5"/>
+      <p:sp>
+        <p:nvSpPr>
+          <p:cNvPr id="4" name="TextBox 3"/>
           <p:cNvSpPr txBox="1"/>
           <p:nvPr/>
         </p:nvSpPr>
         <p:spPr>
           <a:xfrm>
-            <a:off x="7516368" y="1938528"/>
-            <a:ext cx="3794760" cy="365760"/>
+            <a:off x="685800" y="1828800"/>
+            <a:ext cx="10972800" cy="4480560"/>
+          </a:xfrm>
+          <a:prstGeom prst="rect">
+            <a:avLst/>
+          </a:prstGeom>
+          <a:noFill/>
+        </p:spPr>
+        <p:txBody>
+          <a:bodyPr wrap="square">
+            <a:spAutoFit/>
+          </a:bodyPr>
+          <a:lstStyle/>
+          <a:p>
+            <a:pPr>
+              <a:spcAft>
+                <a:spcPts val="900"/>
+              </a:spcAft>
+              <a:defRPr sz="1900">
+                <a:solidFill>
+                  <a:srgbClr val="1C2D46"/>
+                </a:solidFill>
+                <a:latin typeface="Aptos"/>
+              </a:defRPr>
+            </a:pPr>
+            <a:r>
+              <a:t>1) Data cleaning + beauty/noise filter</a:t>
+            </a:r>
+          </a:p>
+          <a:p>
+            <a:pPr>
+              <a:spcAft>
+                <a:spcPts val="900"/>
+              </a:spcAft>
+              <a:defRPr sz="1900">
+                <a:solidFill>
+                  <a:srgbClr val="1C2D46"/>
+                </a:solidFill>
+                <a:latin typeface="Aptos"/>
+              </a:defRPr>
+            </a:pPr>
+            <a:r>
+              <a:t>2) Channel aggregation and text profile generation</a:t>
+            </a:r>
+          </a:p>
+          <a:p>
+            <a:pPr>
+              <a:spcAft>
+                <a:spcPts val="900"/>
+              </a:spcAft>
+              <a:defRPr sz="1900">
+                <a:solidFill>
+                  <a:srgbClr val="1C2D46"/>
+                </a:solidFill>
+                <a:latin typeface="Aptos"/>
+              </a:defRPr>
+            </a:pPr>
+            <a:r>
+              <a:t>3) Network scoring (centrality + community detection)</a:t>
+            </a:r>
+          </a:p>
+          <a:p>
+            <a:pPr>
+              <a:spcAft>
+                <a:spcPts val="900"/>
+              </a:spcAft>
+              <a:defRPr sz="1900">
+                <a:solidFill>
+                  <a:srgbClr val="1C2D46"/>
+                </a:solidFill>
+                <a:latin typeface="Aptos"/>
+              </a:defRPr>
+            </a:pPr>
+            <a:r>
+              <a:t>4) TF-IDF relevance + semantic/tone enrichment</a:t>
+            </a:r>
+          </a:p>
+          <a:p>
+            <a:pPr>
+              <a:spcAft>
+                <a:spcPts val="900"/>
+              </a:spcAft>
+              <a:defRPr sz="1900">
+                <a:solidFill>
+                  <a:srgbClr val="1C2D46"/>
+                </a:solidFill>
+                <a:latin typeface="Aptos"/>
+              </a:defRPr>
+            </a:pPr>
+            <a:r>
+              <a:t>5) Evidence guardrail + diversity-aware ranking</a:t>
+            </a:r>
+          </a:p>
+          <a:p>
+            <a:pPr>
+              <a:spcAft>
+                <a:spcPts val="900"/>
+              </a:spcAft>
+              <a:defRPr sz="1900">
+                <a:solidFill>
+                  <a:srgbClr val="1C2D46"/>
+                </a:solidFill>
+                <a:latin typeface="Aptos"/>
+              </a:defRPr>
+            </a:pPr>
+            <a:r>
+              <a:t>6) ML benchmark (Linear/LASSO/Ridge/CART/RF/LightGBM, GroupKFold 5-fold)</a:t>
+            </a:r>
+          </a:p>
+          <a:p>
+            <a:pPr>
+              <a:spcAft>
+                <a:spcPts val="900"/>
+              </a:spcAft>
+              <a:defRPr sz="1900">
+                <a:solidFill>
+                  <a:srgbClr val="1C2D46"/>
+                </a:solidFill>
+                <a:latin typeface="Aptos"/>
+              </a:defRPr>
+            </a:pPr>
+            <a:r>
+              <a:t>7) ROI simulation + strategy generation + executive memo</a:t>
+            </a:r>
+          </a:p>
+        </p:txBody>
+      </p:sp>
+      <p:sp>
+        <p:nvSpPr>
+          <p:cNvPr id="5" name="TextBox 4"/>
+          <p:cNvSpPr txBox="1"/>
+          <p:nvPr/>
+        </p:nvSpPr>
+        <p:spPr>
+          <a:xfrm>
+            <a:off x="502920" y="6428232"/>
+            <a:ext cx="10972800" cy="292608"/>
           </a:xfrm>
           <a:prstGeom prst="rect">
             <a:avLst/>
@@ -7627,129 +8252,6 @@
           </a:bodyPr>
           <a:lstStyle/>
           <a:p>
-            <a:pPr>
-              <a:defRPr b="1" sz="1900">
-                <a:solidFill>
-                  <a:srgbClr val="133A66"/>
-                </a:solidFill>
-                <a:latin typeface="Aptos"/>
-              </a:defRPr>
-            </a:pPr>
-            <a:r>
-              <a:t>Best model: LightGBM</a:t>
-            </a:r>
-          </a:p>
-        </p:txBody>
-      </p:sp>
-      <p:sp>
-        <p:nvSpPr>
-          <p:cNvPr id="7" name="TextBox 6"/>
-          <p:cNvSpPr txBox="1"/>
-          <p:nvPr/>
-        </p:nvSpPr>
-        <p:spPr>
-          <a:xfrm>
-            <a:off x="7498079" y="2304288"/>
-            <a:ext cx="3794760" cy="3730752"/>
-          </a:xfrm>
-          <a:prstGeom prst="rect">
-            <a:avLst/>
-          </a:prstGeom>
-          <a:noFill/>
-        </p:spPr>
-        <p:txBody>
-          <a:bodyPr wrap="square">
-            <a:spAutoFit/>
-          </a:bodyPr>
-          <a:lstStyle/>
-          <a:p>
-            <a:pPr>
-              <a:spcAft>
-                <a:spcPts val="900"/>
-              </a:spcAft>
-              <a:defRPr sz="1600">
-                <a:solidFill>
-                  <a:srgbClr val="1C2D46"/>
-                </a:solidFill>
-                <a:latin typeface="Aptos"/>
-              </a:defRPr>
-            </a:pPr>
-            <a:r>
-              <a:t>Best RMSE: 0.00996</a:t>
-            </a:r>
-          </a:p>
-          <a:p>
-            <a:pPr>
-              <a:spcAft>
-                <a:spcPts val="900"/>
-              </a:spcAft>
-              <a:defRPr sz="1600">
-                <a:solidFill>
-                  <a:srgbClr val="1C2D46"/>
-                </a:solidFill>
-                <a:latin typeface="Aptos"/>
-              </a:defRPr>
-            </a:pPr>
-            <a:r>
-              <a:t>Baseline RMSE: 0.03800</a:t>
-            </a:r>
-          </a:p>
-          <a:p>
-            <a:pPr>
-              <a:spcAft>
-                <a:spcPts val="900"/>
-              </a:spcAft>
-              <a:defRPr sz="1600">
-                <a:solidFill>
-                  <a:srgbClr val="1C2D46"/>
-                </a:solidFill>
-                <a:latin typeface="Aptos"/>
-              </a:defRPr>
-            </a:pPr>
-            <a:r>
-              <a:t>RMSE reduction vs baseline: 73.8%</a:t>
-            </a:r>
-          </a:p>
-          <a:p>
-            <a:pPr>
-              <a:spcAft>
-                <a:spcPts val="900"/>
-              </a:spcAft>
-              <a:defRPr sz="1600">
-                <a:solidFill>
-                  <a:srgbClr val="1C2D46"/>
-                </a:solidFill>
-                <a:latin typeface="Aptos"/>
-              </a:defRPr>
-            </a:pPr>
-            <a:r>
-              <a:t>Group-based CV used to reduce channel leakage risk</a:t>
-            </a:r>
-          </a:p>
-        </p:txBody>
-      </p:sp>
-      <p:sp>
-        <p:nvSpPr>
-          <p:cNvPr id="8" name="TextBox 7"/>
-          <p:cNvSpPr txBox="1"/>
-          <p:nvPr/>
-        </p:nvSpPr>
-        <p:spPr>
-          <a:xfrm>
-            <a:off x="502920" y="6428232"/>
-            <a:ext cx="10972800" cy="292608"/>
-          </a:xfrm>
-          <a:prstGeom prst="rect">
-            <a:avLst/>
-          </a:prstGeom>
-          <a:noFill/>
-        </p:spPr>
-        <p:txBody>
-          <a:bodyPr wrap="none">
-            <a:spAutoFit/>
-          </a:bodyPr>
-          <a:lstStyle/>
-          <a:p>
             <a:pPr algn="r">
               <a:defRPr sz="1000">
                 <a:solidFill>
@@ -7759,7 +8261,7 @@
               </a:defRPr>
             </a:pPr>
             <a:r>
-              <a:t>6 models compared under the same CV protocol</a:t>
+              <a:t>Rubric 3: Technical aspects and method choice</a:t>
             </a:r>
           </a:p>
         </p:txBody>
@@ -7813,7 +8315,7 @@
               </a:defRPr>
             </a:pPr>
             <a:r>
-              <a:t>Explainability (SHAP)</a:t>
+              <a:t>Model Evaluation Results</a:t>
             </a:r>
           </a:p>
         </p:txBody>
@@ -7863,7 +8365,7 @@
       </p:sp>
       <p:pic>
         <p:nvPicPr>
-          <p:cNvPr id="4" name="Picture 3" descr="shap_summary_LightGBM.png"/>
+          <p:cNvPr id="4" name="Picture 3" descr="model_benchmark_rmse.png"/>
           <p:cNvPicPr>
             <a:picLocks noChangeAspect="1"/>
           </p:cNvPicPr>
@@ -7877,8 +8379,8 @@
         </p:blipFill>
         <p:spPr>
           <a:xfrm>
-            <a:off x="685800" y="1828800"/>
-            <a:ext cx="7340308" cy="4389120"/>
+            <a:off x="731520" y="1828800"/>
+            <a:ext cx="8237220" cy="4297680"/>
           </a:xfrm>
           <a:prstGeom prst="rect">
             <a:avLst/>
@@ -7893,8 +8395,8 @@
         </p:nvSpPr>
         <p:spPr>
           <a:xfrm>
-            <a:off x="7269480" y="1828800"/>
-            <a:ext cx="4206240" cy="4389120"/>
+            <a:off x="7315200" y="1828800"/>
+            <a:ext cx="4114800" cy="4297680"/>
           </a:xfrm>
           <a:prstGeom prst="roundRect">
             <a:avLst/>
@@ -7938,8 +8440,8 @@
         </p:nvSpPr>
         <p:spPr>
           <a:xfrm>
-            <a:off x="7470648" y="1938528"/>
-            <a:ext cx="3886200" cy="365760"/>
+            <a:off x="7516368" y="1938528"/>
+            <a:ext cx="3794760" cy="365760"/>
           </a:xfrm>
           <a:prstGeom prst="rect">
             <a:avLst/>
@@ -7961,7 +8463,7 @@
               </a:defRPr>
             </a:pPr>
             <a:r>
-              <a:t>Why SHAP matters</a:t>
+              <a:t>Best model: LightGBM</a:t>
             </a:r>
           </a:p>
         </p:txBody>
@@ -7974,8 +8476,8 @@
         </p:nvSpPr>
         <p:spPr>
           <a:xfrm>
-            <a:off x="7452360" y="2304288"/>
-            <a:ext cx="3886200" cy="3822191"/>
+            <a:off x="7498079" y="2304288"/>
+            <a:ext cx="3794760" cy="3730752"/>
           </a:xfrm>
           <a:prstGeom prst="rect">
             <a:avLst/>
@@ -8000,7 +8502,7 @@
               </a:defRPr>
             </a:pPr>
             <a:r>
-              <a:t>Shows which features drive engagement predictions.</a:t>
+              <a:t>Best RMSE: 0.00996</a:t>
             </a:r>
           </a:p>
           <a:p>
@@ -8016,7 +8518,7 @@
               </a:defRPr>
             </a:pPr>
             <a:r>
-              <a:t>Improves trust for non-technical stakeholders.</a:t>
+              <a:t>Baseline RMSE: 0.03800</a:t>
             </a:r>
           </a:p>
           <a:p>
@@ -8032,7 +8534,23 @@
               </a:defRPr>
             </a:pPr>
             <a:r>
-              <a:t>Helps diagnose unstable or misleading signals.</a:t>
+              <a:t>RMSE reduction vs baseline: 73.8%</a:t>
+            </a:r>
+          </a:p>
+          <a:p>
+            <a:pPr>
+              <a:spcAft>
+                <a:spcPts val="900"/>
+              </a:spcAft>
+              <a:defRPr sz="1600">
+                <a:solidFill>
+                  <a:srgbClr val="1C2D46"/>
+                </a:solidFill>
+                <a:latin typeface="Aptos"/>
+              </a:defRPr>
+            </a:pPr>
+            <a:r>
+              <a:t>Group-based CV used to reduce channel leakage risk</a:t>
             </a:r>
           </a:p>
         </p:txBody>
@@ -8068,7 +8586,7 @@
               </a:defRPr>
             </a:pPr>
             <a:r>
-              <a:t>Rubric 3: Evaluation and sanity checking</a:t>
+              <a:t>6 models compared under the same CV protocol</a:t>
             </a:r>
           </a:p>
         </p:txBody>
@@ -8122,7 +8640,7 @@
               </a:defRPr>
             </a:pPr>
             <a:r>
-              <a:t>Top-10 BOJ Recommendations</a:t>
+              <a:t>Explainability (SHAP)</a:t>
             </a:r>
           </a:p>
         </p:txBody>
@@ -8172,7 +8690,7 @@
       </p:sp>
       <p:pic>
         <p:nvPicPr>
-          <p:cNvPr id="4" name="Picture 3" descr="top10_final_scores.png"/>
+          <p:cNvPr id="4" name="Picture 3" descr="shap_summary_LightGBM.png"/>
           <p:cNvPicPr>
             <a:picLocks noChangeAspect="1"/>
           </p:cNvPicPr>
@@ -8186,8 +8704,8 @@
         </p:blipFill>
         <p:spPr>
           <a:xfrm>
-            <a:off x="658368" y="1828800"/>
-            <a:ext cx="8704385" cy="4526280"/>
+            <a:off x="685800" y="1828800"/>
+            <a:ext cx="7340308" cy="4389120"/>
           </a:xfrm>
           <a:prstGeom prst="rect">
             <a:avLst/>
@@ -8196,14 +8714,59 @@
       </p:pic>
       <p:sp>
         <p:nvSpPr>
-          <p:cNvPr id="5" name="TextBox 4"/>
+          <p:cNvPr id="5" name="Rounded Rectangle 4"/>
+          <p:cNvSpPr/>
+          <p:nvPr/>
+        </p:nvSpPr>
+        <p:spPr>
+          <a:xfrm>
+            <a:off x="7269480" y="1828800"/>
+            <a:ext cx="4206240" cy="4389120"/>
+          </a:xfrm>
+          <a:prstGeom prst="roundRect">
+            <a:avLst/>
+          </a:prstGeom>
+          <a:solidFill>
+            <a:srgbClr val="F2F7FC"/>
+          </a:solidFill>
+          <a:ln w="15875">
+            <a:solidFill>
+              <a:srgbClr val="CDDCEE"/>
+            </a:solidFill>
+          </a:ln>
+        </p:spPr>
+        <p:style>
+          <a:lnRef idx="1">
+            <a:schemeClr val="accent1"/>
+          </a:lnRef>
+          <a:fillRef idx="3">
+            <a:schemeClr val="accent1"/>
+          </a:fillRef>
+          <a:effectRef idx="2">
+            <a:schemeClr val="accent1"/>
+          </a:effectRef>
+          <a:fontRef idx="minor">
+            <a:schemeClr val="lt1"/>
+          </a:fontRef>
+        </p:style>
+        <p:txBody>
+          <a:bodyPr rtlCol="0" anchor="ctr"/>
+          <a:lstStyle/>
+          <a:p>
+            <a:pPr algn="ctr"/>
+          </a:p>
+        </p:txBody>
+      </p:sp>
+      <p:sp>
+        <p:nvSpPr>
+          <p:cNvPr id="6" name="TextBox 5"/>
           <p:cNvSpPr txBox="1"/>
           <p:nvPr/>
         </p:nvSpPr>
         <p:spPr>
           <a:xfrm>
-            <a:off x="502920" y="6428232"/>
-            <a:ext cx="10972800" cy="292608"/>
+            <a:off x="7470648" y="1938528"/>
+            <a:ext cx="3886200" cy="365760"/>
           </a:xfrm>
           <a:prstGeom prst="rect">
             <a:avLst/>
@@ -8216,6 +8779,113 @@
           </a:bodyPr>
           <a:lstStyle/>
           <a:p>
+            <a:pPr>
+              <a:defRPr b="1" sz="1900">
+                <a:solidFill>
+                  <a:srgbClr val="133A66"/>
+                </a:solidFill>
+                <a:latin typeface="Aptos"/>
+              </a:defRPr>
+            </a:pPr>
+            <a:r>
+              <a:t>Why SHAP matters</a:t>
+            </a:r>
+          </a:p>
+        </p:txBody>
+      </p:sp>
+      <p:sp>
+        <p:nvSpPr>
+          <p:cNvPr id="7" name="TextBox 6"/>
+          <p:cNvSpPr txBox="1"/>
+          <p:nvPr/>
+        </p:nvSpPr>
+        <p:spPr>
+          <a:xfrm>
+            <a:off x="7452360" y="2304288"/>
+            <a:ext cx="3886200" cy="3822191"/>
+          </a:xfrm>
+          <a:prstGeom prst="rect">
+            <a:avLst/>
+          </a:prstGeom>
+          <a:noFill/>
+        </p:spPr>
+        <p:txBody>
+          <a:bodyPr wrap="square">
+            <a:spAutoFit/>
+          </a:bodyPr>
+          <a:lstStyle/>
+          <a:p>
+            <a:pPr>
+              <a:spcAft>
+                <a:spcPts val="900"/>
+              </a:spcAft>
+              <a:defRPr sz="1600">
+                <a:solidFill>
+                  <a:srgbClr val="1C2D46"/>
+                </a:solidFill>
+                <a:latin typeface="Aptos"/>
+              </a:defRPr>
+            </a:pPr>
+            <a:r>
+              <a:t>Shows which features drive engagement predictions.</a:t>
+            </a:r>
+          </a:p>
+          <a:p>
+            <a:pPr>
+              <a:spcAft>
+                <a:spcPts val="900"/>
+              </a:spcAft>
+              <a:defRPr sz="1600">
+                <a:solidFill>
+                  <a:srgbClr val="1C2D46"/>
+                </a:solidFill>
+                <a:latin typeface="Aptos"/>
+              </a:defRPr>
+            </a:pPr>
+            <a:r>
+              <a:t>Improves trust for non-technical stakeholders.</a:t>
+            </a:r>
+          </a:p>
+          <a:p>
+            <a:pPr>
+              <a:spcAft>
+                <a:spcPts val="900"/>
+              </a:spcAft>
+              <a:defRPr sz="1600">
+                <a:solidFill>
+                  <a:srgbClr val="1C2D46"/>
+                </a:solidFill>
+                <a:latin typeface="Aptos"/>
+              </a:defRPr>
+            </a:pPr>
+            <a:r>
+              <a:t>Helps diagnose unstable or misleading signals.</a:t>
+            </a:r>
+          </a:p>
+        </p:txBody>
+      </p:sp>
+      <p:sp>
+        <p:nvSpPr>
+          <p:cNvPr id="8" name="TextBox 7"/>
+          <p:cNvSpPr txBox="1"/>
+          <p:nvPr/>
+        </p:nvSpPr>
+        <p:spPr>
+          <a:xfrm>
+            <a:off x="502920" y="6428232"/>
+            <a:ext cx="10972800" cy="292608"/>
+          </a:xfrm>
+          <a:prstGeom prst="rect">
+            <a:avLst/>
+          </a:prstGeom>
+          <a:noFill/>
+        </p:spPr>
+        <p:txBody>
+          <a:bodyPr wrap="none">
+            <a:spAutoFit/>
+          </a:bodyPr>
+          <a:lstStyle/>
+          <a:p>
             <a:pPr algn="r">
               <a:defRPr sz="1000">
                 <a:solidFill>
@@ -8225,7 +8895,7 @@
               </a:defRPr>
             </a:pPr>
             <a:r>
-              <a:t>Top 3 channels: AliceintheRabbitHole, Dr. Sam Ellis, NikkieTutorials</a:t>
+              <a:t>Rubric 3: Evaluation and sanity checking</a:t>
             </a:r>
           </a:p>
         </p:txBody>
@@ -8279,7 +8949,7 @@
               </a:defRPr>
             </a:pPr>
             <a:r>
-              <a:t>Guardrails Against Bad Recommendations</a:t>
+              <a:t>Top-10 BOJ Recommendations</a:t>
             </a:r>
           </a:p>
         </p:txBody>
@@ -8329,7 +8999,7 @@
       </p:sp>
       <p:pic>
         <p:nvPicPr>
-          <p:cNvPr id="4" name="Picture 3" descr="evidence_vs_finalscore_top10.png"/>
+          <p:cNvPr id="4" name="Picture 3" descr="top10_final_scores.png"/>
           <p:cNvPicPr>
             <a:picLocks noChangeAspect="1"/>
           </p:cNvPicPr>
@@ -8343,8 +9013,8 @@
         </p:blipFill>
         <p:spPr>
           <a:xfrm>
-            <a:off x="685800" y="1828800"/>
-            <a:ext cx="6993402" cy="4434840"/>
+            <a:off x="658368" y="1828800"/>
+            <a:ext cx="8704385" cy="4526280"/>
           </a:xfrm>
           <a:prstGeom prst="rect">
             <a:avLst/>
@@ -8353,59 +9023,14 @@
       </p:pic>
       <p:sp>
         <p:nvSpPr>
-          <p:cNvPr id="5" name="Rounded Rectangle 4"/>
-          <p:cNvSpPr/>
-          <p:nvPr/>
-        </p:nvSpPr>
-        <p:spPr>
-          <a:xfrm>
-            <a:off x="7342631" y="1828800"/>
-            <a:ext cx="4069080" cy="4434840"/>
-          </a:xfrm>
-          <a:prstGeom prst="roundRect">
-            <a:avLst/>
-          </a:prstGeom>
-          <a:solidFill>
-            <a:srgbClr val="F2F7FC"/>
-          </a:solidFill>
-          <a:ln w="15875">
-            <a:solidFill>
-              <a:srgbClr val="CDDCEE"/>
-            </a:solidFill>
-          </a:ln>
-        </p:spPr>
-        <p:style>
-          <a:lnRef idx="1">
-            <a:schemeClr val="accent1"/>
-          </a:lnRef>
-          <a:fillRef idx="3">
-            <a:schemeClr val="accent1"/>
-          </a:fillRef>
-          <a:effectRef idx="2">
-            <a:schemeClr val="accent1"/>
-          </a:effectRef>
-          <a:fontRef idx="minor">
-            <a:schemeClr val="lt1"/>
-          </a:fontRef>
-        </p:style>
-        <p:txBody>
-          <a:bodyPr rtlCol="0" anchor="ctr"/>
-          <a:lstStyle/>
-          <a:p>
-            <a:pPr algn="ctr"/>
-          </a:p>
-        </p:txBody>
-      </p:sp>
-      <p:sp>
-        <p:nvSpPr>
-          <p:cNvPr id="6" name="TextBox 5"/>
+          <p:cNvPr id="5" name="TextBox 4"/>
           <p:cNvSpPr txBox="1"/>
           <p:nvPr/>
         </p:nvSpPr>
         <p:spPr>
           <a:xfrm>
-            <a:off x="7543800" y="1938528"/>
-            <a:ext cx="3749040" cy="365760"/>
+            <a:off x="502920" y="6428232"/>
+            <a:ext cx="10972800" cy="292608"/>
           </a:xfrm>
           <a:prstGeom prst="rect">
             <a:avLst/>
@@ -8418,113 +9043,6 @@
           </a:bodyPr>
           <a:lstStyle/>
           <a:p>
-            <a:pPr>
-              <a:defRPr b="1" sz="1900">
-                <a:solidFill>
-                  <a:srgbClr val="133A66"/>
-                </a:solidFill>
-                <a:latin typeface="Aptos"/>
-              </a:defRPr>
-            </a:pPr>
-            <a:r>
-              <a:t>Bias and quality controls</a:t>
-            </a:r>
-          </a:p>
-        </p:txBody>
-      </p:sp>
-      <p:sp>
-        <p:nvSpPr>
-          <p:cNvPr id="7" name="TextBox 6"/>
-          <p:cNvSpPr txBox="1"/>
-          <p:nvPr/>
-        </p:nvSpPr>
-        <p:spPr>
-          <a:xfrm>
-            <a:off x="7525511" y="2304288"/>
-            <a:ext cx="3749040" cy="3867911"/>
-          </a:xfrm>
-          <a:prstGeom prst="rect">
-            <a:avLst/>
-          </a:prstGeom>
-          <a:noFill/>
-        </p:spPr>
-        <p:txBody>
-          <a:bodyPr wrap="square">
-            <a:spAutoFit/>
-          </a:bodyPr>
-          <a:lstStyle/>
-          <a:p>
-            <a:pPr>
-              <a:spcAft>
-                <a:spcPts val="900"/>
-              </a:spcAft>
-              <a:defRPr sz="1600">
-                <a:solidFill>
-                  <a:srgbClr val="1C2D46"/>
-                </a:solidFill>
-                <a:latin typeface="Aptos"/>
-              </a:defRPr>
-            </a:pPr>
-            <a:r>
-              <a:t>Low-evidence channels are automatically down-weighted.</a:t>
-            </a:r>
-          </a:p>
-          <a:p>
-            <a:pPr>
-              <a:spcAft>
-                <a:spcPts val="900"/>
-              </a:spcAft>
-              <a:defRPr sz="1600">
-                <a:solidFill>
-                  <a:srgbClr val="1C2D46"/>
-                </a:solidFill>
-                <a:latin typeface="Aptos"/>
-              </a:defRPr>
-            </a:pPr>
-            <a:r>
-              <a:t>Diversity guardrail prevents single-cluster over-concentration.</a:t>
-            </a:r>
-          </a:p>
-          <a:p>
-            <a:pPr>
-              <a:spcAft>
-                <a:spcPts val="900"/>
-              </a:spcAft>
-              <a:defRPr sz="1600">
-                <a:solidFill>
-                  <a:srgbClr val="1C2D46"/>
-                </a:solidFill>
-                <a:latin typeface="Aptos"/>
-              </a:defRPr>
-            </a:pPr>
-            <a:r>
-              <a:t>Degree-only vs hybrid overlap: 2/10</a:t>
-            </a:r>
-          </a:p>
-        </p:txBody>
-      </p:sp>
-      <p:sp>
-        <p:nvSpPr>
-          <p:cNvPr id="8" name="TextBox 7"/>
-          <p:cNvSpPr txBox="1"/>
-          <p:nvPr/>
-        </p:nvSpPr>
-        <p:spPr>
-          <a:xfrm>
-            <a:off x="502920" y="6428232"/>
-            <a:ext cx="10972800" cy="292608"/>
-          </a:xfrm>
-          <a:prstGeom prst="rect">
-            <a:avLst/>
-          </a:prstGeom>
-          <a:noFill/>
-        </p:spPr>
-        <p:txBody>
-          <a:bodyPr wrap="none">
-            <a:spAutoFit/>
-          </a:bodyPr>
-          <a:lstStyle/>
-          <a:p>
             <a:pPr algn="r">
               <a:defRPr sz="1000">
                 <a:solidFill>
@@ -8534,7 +9052,7 @@
               </a:defRPr>
             </a:pPr>
             <a:r>
-              <a:t>Reduced popularity bias with evidence-based filtering</a:t>
+              <a:t>Top 3 channels: AliceintheRabbitHole, Dr. Sam Ellis, NikkieTutorials</a:t>
             </a:r>
           </a:p>
         </p:txBody>

</xml_diff>

<commit_message>
Expand research references and add per-slide source links
</commit_message>
<xml_diff>
--- a/slides/AI_MCN_Final_Presentation_EN.pptx
+++ b/slides/AI_MCN_Final_Presentation_EN.pptx
@@ -3297,7 +3297,7 @@
         <p:spPr>
           <a:xfrm>
             <a:off x="502920" y="6428232"/>
-            <a:ext cx="10972800" cy="292608"/>
+            <a:ext cx="8503920" cy="310896"/>
           </a:xfrm>
           <a:prstGeom prst="rect">
             <a:avLst/>
@@ -3310,8 +3310,76 @@
           </a:bodyPr>
           <a:lstStyle/>
           <a:p>
+            <a:pPr algn="l">
+              <a:spcAft>
+                <a:spcPts val="0"/>
+              </a:spcAft>
+            </a:pPr>
+            <a:r>
+              <a:rPr sz="850">
+                <a:solidFill>
+                  <a:srgbClr val="6E8098"/>
+                </a:solidFill>
+                <a:latin typeface="Aptos"/>
+              </a:rPr>
+              <a:t>Sources: </a:t>
+            </a:r>
+            <a:r>
+              <a:rPr sz="850" u="sng">
+                <a:solidFill>
+                  <a:srgbClr val="1A7DBC"/>
+                </a:solidFill>
+                <a:latin typeface="Aptos"/>
+                <a:hlinkClick r:id="rId2"/>
+              </a:rPr>
+              <a:t>GitHub repo</a:t>
+            </a:r>
+            <a:r>
+              <a:rPr sz="850">
+                <a:solidFill>
+                  <a:srgbClr val="8291A5"/>
+                </a:solidFill>
+                <a:latin typeface="Aptos"/>
+              </a:rPr>
+              <a:t> | </a:t>
+            </a:r>
+            <a:r>
+              <a:rPr sz="850" u="sng">
+                <a:solidFill>
+                  <a:srgbClr val="1A7DBC"/>
+                </a:solidFill>
+                <a:latin typeface="Aptos"/>
+                <a:hlinkClick r:id="rId3"/>
+              </a:rPr>
+              <a:t>EMARKETER 2025</a:t>
+            </a:r>
+          </a:p>
+        </p:txBody>
+      </p:sp>
+      <p:sp>
+        <p:nvSpPr>
+          <p:cNvPr id="7" name="TextBox 6"/>
+          <p:cNvSpPr txBox="1"/>
+          <p:nvPr/>
+        </p:nvSpPr>
+        <p:spPr>
+          <a:xfrm>
+            <a:off x="9189720" y="6428232"/>
+            <a:ext cx="2514600" cy="292608"/>
+          </a:xfrm>
+          <a:prstGeom prst="rect">
+            <a:avLst/>
+          </a:prstGeom>
+          <a:noFill/>
+        </p:spPr>
+        <p:txBody>
+          <a:bodyPr wrap="none">
+            <a:spAutoFit/>
+          </a:bodyPr>
+          <a:lstStyle/>
+          <a:p>
             <a:pPr algn="r">
-              <a:defRPr sz="1000">
+              <a:defRPr sz="900">
                 <a:solidFill>
                   <a:srgbClr val="6E8098"/>
                 </a:solidFill>
@@ -3622,7 +3690,7 @@
         <p:spPr>
           <a:xfrm>
             <a:off x="502920" y="6428232"/>
-            <a:ext cx="10972800" cy="292608"/>
+            <a:ext cx="8503920" cy="310896"/>
           </a:xfrm>
           <a:prstGeom prst="rect">
             <a:avLst/>
@@ -3635,8 +3703,75 @@
           </a:bodyPr>
           <a:lstStyle/>
           <a:p>
+            <a:pPr algn="l">
+              <a:spcAft>
+                <a:spcPts val="0"/>
+              </a:spcAft>
+            </a:pPr>
+            <a:r>
+              <a:rPr sz="850">
+                <a:solidFill>
+                  <a:srgbClr val="6E8098"/>
+                </a:solidFill>
+                <a:latin typeface="Aptos"/>
+              </a:rPr>
+              <a:t>Sources: </a:t>
+            </a:r>
+            <a:r>
+              <a:rPr sz="850">
+                <a:solidFill>
+                  <a:srgbClr val="6E8098"/>
+                </a:solidFill>
+                <a:latin typeface="Aptos"/>
+              </a:rPr>
+              <a:t>ML CV outputs (internal)</a:t>
+            </a:r>
+            <a:r>
+              <a:rPr sz="850">
+                <a:solidFill>
+                  <a:srgbClr val="8291A5"/>
+                </a:solidFill>
+                <a:latin typeface="Aptos"/>
+              </a:rPr>
+              <a:t> | </a:t>
+            </a:r>
+            <a:r>
+              <a:rPr sz="850" u="sng">
+                <a:solidFill>
+                  <a:srgbClr val="1A7DBC"/>
+                </a:solidFill>
+                <a:latin typeface="Aptos"/>
+                <a:hlinkClick r:id="rId3"/>
+              </a:rPr>
+              <a:t>LightGBM docs</a:t>
+            </a:r>
+          </a:p>
+        </p:txBody>
+      </p:sp>
+      <p:sp>
+        <p:nvSpPr>
+          <p:cNvPr id="9" name="TextBox 8"/>
+          <p:cNvSpPr txBox="1"/>
+          <p:nvPr/>
+        </p:nvSpPr>
+        <p:spPr>
+          <a:xfrm>
+            <a:off x="9189720" y="6428232"/>
+            <a:ext cx="2514600" cy="292608"/>
+          </a:xfrm>
+          <a:prstGeom prst="rect">
+            <a:avLst/>
+          </a:prstGeom>
+          <a:noFill/>
+        </p:spPr>
+        <p:txBody>
+          <a:bodyPr wrap="none">
+            <a:spAutoFit/>
+          </a:bodyPr>
+          <a:lstStyle/>
+          <a:p>
             <a:pPr algn="r">
-              <a:defRPr sz="1000">
+              <a:defRPr sz="900">
                 <a:solidFill>
                   <a:srgbClr val="6E8098"/>
                 </a:solidFill>
@@ -3882,7 +4017,7 @@
         <p:spPr>
           <a:xfrm>
             <a:off x="502920" y="6428232"/>
-            <a:ext cx="10972800" cy="292608"/>
+            <a:ext cx="8503920" cy="310896"/>
           </a:xfrm>
           <a:prstGeom prst="rect">
             <a:avLst/>
@@ -3895,8 +4030,75 @@
           </a:bodyPr>
           <a:lstStyle/>
           <a:p>
+            <a:pPr algn="l">
+              <a:spcAft>
+                <a:spcPts val="0"/>
+              </a:spcAft>
+            </a:pPr>
+            <a:r>
+              <a:rPr sz="850">
+                <a:solidFill>
+                  <a:srgbClr val="6E8098"/>
+                </a:solidFill>
+                <a:latin typeface="Aptos"/>
+              </a:rPr>
+              <a:t>Sources: </a:t>
+            </a:r>
+            <a:r>
+              <a:rPr sz="850" u="sng">
+                <a:solidFill>
+                  <a:srgbClr val="1A7DBC"/>
+                </a:solidFill>
+                <a:latin typeface="Aptos"/>
+                <a:hlinkClick r:id="rId3"/>
+              </a:rPr>
+              <a:t>Streamlit docs</a:t>
+            </a:r>
+            <a:r>
+              <a:rPr sz="850">
+                <a:solidFill>
+                  <a:srgbClr val="8291A5"/>
+                </a:solidFill>
+                <a:latin typeface="Aptos"/>
+              </a:rPr>
+              <a:t> | </a:t>
+            </a:r>
+            <a:r>
+              <a:rPr sz="850">
+                <a:solidFill>
+                  <a:srgbClr val="6E8098"/>
+                </a:solidFill>
+                <a:latin typeface="Aptos"/>
+              </a:rPr>
+              <a:t>Prototype app/pipeline (internal)</a:t>
+            </a:r>
+          </a:p>
+        </p:txBody>
+      </p:sp>
+      <p:sp>
+        <p:nvSpPr>
+          <p:cNvPr id="7" name="TextBox 6"/>
+          <p:cNvSpPr txBox="1"/>
+          <p:nvPr/>
+        </p:nvSpPr>
+        <p:spPr>
+          <a:xfrm>
+            <a:off x="9189720" y="6428232"/>
+            <a:ext cx="2514600" cy="292608"/>
+          </a:xfrm>
+          <a:prstGeom prst="rect">
+            <a:avLst/>
+          </a:prstGeom>
+          <a:noFill/>
+        </p:spPr>
+        <p:txBody>
+          <a:bodyPr wrap="none">
+            <a:spAutoFit/>
+          </a:bodyPr>
+          <a:lstStyle/>
+          <a:p>
             <a:pPr algn="r">
-              <a:defRPr sz="1000">
+              <a:defRPr sz="900">
                 <a:solidFill>
                   <a:srgbClr val="6E8098"/>
                 </a:solidFill>
@@ -4351,7 +4553,7 @@
         <p:spPr>
           <a:xfrm>
             <a:off x="502920" y="6428232"/>
-            <a:ext cx="10972800" cy="292608"/>
+            <a:ext cx="8503920" cy="310896"/>
           </a:xfrm>
           <a:prstGeom prst="rect">
             <a:avLst/>
@@ -4364,8 +4566,76 @@
           </a:bodyPr>
           <a:lstStyle/>
           <a:p>
+            <a:pPr algn="l">
+              <a:spcAft>
+                <a:spcPts val="0"/>
+              </a:spcAft>
+            </a:pPr>
+            <a:r>
+              <a:rPr sz="850">
+                <a:solidFill>
+                  <a:srgbClr val="6E8098"/>
+                </a:solidFill>
+                <a:latin typeface="Aptos"/>
+              </a:rPr>
+              <a:t>Sources: </a:t>
+            </a:r>
+            <a:r>
+              <a:rPr sz="850" u="sng">
+                <a:solidFill>
+                  <a:srgbClr val="1A7DBC"/>
+                </a:solidFill>
+                <a:latin typeface="Aptos"/>
+                <a:hlinkClick r:id="rId2"/>
+              </a:rPr>
+              <a:t>IAB Creator Economy</a:t>
+            </a:r>
+            <a:r>
+              <a:rPr sz="850">
+                <a:solidFill>
+                  <a:srgbClr val="8291A5"/>
+                </a:solidFill>
+                <a:latin typeface="Aptos"/>
+              </a:rPr>
+              <a:t> | </a:t>
+            </a:r>
+            <a:r>
+              <a:rPr sz="850" u="sng">
+                <a:solidFill>
+                  <a:srgbClr val="1A7DBC"/>
+                </a:solidFill>
+                <a:latin typeface="Aptos"/>
+                <a:hlinkClick r:id="rId3"/>
+              </a:rPr>
+              <a:t>YouTube U.S. Impact 2024</a:t>
+            </a:r>
+          </a:p>
+        </p:txBody>
+      </p:sp>
+      <p:sp>
+        <p:nvSpPr>
+          <p:cNvPr id="11" name="TextBox 10"/>
+          <p:cNvSpPr txBox="1"/>
+          <p:nvPr/>
+        </p:nvSpPr>
+        <p:spPr>
+          <a:xfrm>
+            <a:off x="9189720" y="6428232"/>
+            <a:ext cx="2514600" cy="292608"/>
+          </a:xfrm>
+          <a:prstGeom prst="rect">
+            <a:avLst/>
+          </a:prstGeom>
+          <a:noFill/>
+        </p:spPr>
+        <p:txBody>
+          <a:bodyPr wrap="none">
+            <a:spAutoFit/>
+          </a:bodyPr>
+          <a:lstStyle/>
+          <a:p>
             <a:pPr algn="r">
-              <a:defRPr sz="1000">
+              <a:defRPr sz="900">
                 <a:solidFill>
                   <a:srgbClr val="6E8098"/>
                 </a:solidFill>
@@ -4820,7 +5090,7 @@
         <p:spPr>
           <a:xfrm>
             <a:off x="502920" y="6428232"/>
-            <a:ext cx="10972800" cy="292608"/>
+            <a:ext cx="8503920" cy="310896"/>
           </a:xfrm>
           <a:prstGeom prst="rect">
             <a:avLst/>
@@ -4833,8 +5103,95 @@
           </a:bodyPr>
           <a:lstStyle/>
           <a:p>
+            <a:pPr algn="l">
+              <a:spcAft>
+                <a:spcPts val="0"/>
+              </a:spcAft>
+            </a:pPr>
+            <a:r>
+              <a:rPr sz="850">
+                <a:solidFill>
+                  <a:srgbClr val="6E8098"/>
+                </a:solidFill>
+                <a:latin typeface="Aptos"/>
+              </a:rPr>
+              <a:t>Sources: </a:t>
+            </a:r>
+            <a:r>
+              <a:rPr sz="850" u="sng">
+                <a:solidFill>
+                  <a:srgbClr val="1A7DBC"/>
+                </a:solidFill>
+                <a:latin typeface="Aptos"/>
+                <a:hlinkClick r:id="rId2"/>
+              </a:rPr>
+              <a:t>FTC Influencer Disclosures</a:t>
+            </a:r>
+            <a:r>
+              <a:rPr sz="850">
+                <a:solidFill>
+                  <a:srgbClr val="8291A5"/>
+                </a:solidFill>
+                <a:latin typeface="Aptos"/>
+              </a:rPr>
+              <a:t> | </a:t>
+            </a:r>
+            <a:r>
+              <a:rPr sz="850" u="sng">
+                <a:solidFill>
+                  <a:srgbClr val="1A7DBC"/>
+                </a:solidFill>
+                <a:latin typeface="Aptos"/>
+                <a:hlinkClick r:id="rId3"/>
+              </a:rPr>
+              <a:t>SAFE Sunscreen (House)</a:t>
+            </a:r>
+            <a:r>
+              <a:rPr sz="850">
+                <a:solidFill>
+                  <a:srgbClr val="8291A5"/>
+                </a:solidFill>
+                <a:latin typeface="Aptos"/>
+              </a:rPr>
+              <a:t> | </a:t>
+            </a:r>
+            <a:r>
+              <a:rPr sz="850" u="sng">
+                <a:solidFill>
+                  <a:srgbClr val="1A7DBC"/>
+                </a:solidFill>
+                <a:latin typeface="Aptos"/>
+                <a:hlinkClick r:id="rId4"/>
+              </a:rPr>
+              <a:t>FDA SIA</a:t>
+            </a:r>
+          </a:p>
+        </p:txBody>
+      </p:sp>
+      <p:sp>
+        <p:nvSpPr>
+          <p:cNvPr id="11" name="TextBox 10"/>
+          <p:cNvSpPr txBox="1"/>
+          <p:nvPr/>
+        </p:nvSpPr>
+        <p:spPr>
+          <a:xfrm>
+            <a:off x="9189720" y="6428232"/>
+            <a:ext cx="2514600" cy="292608"/>
+          </a:xfrm>
+          <a:prstGeom prst="rect">
+            <a:avLst/>
+          </a:prstGeom>
+          <a:noFill/>
+        </p:spPr>
+        <p:txBody>
+          <a:bodyPr wrap="none">
+            <a:spAutoFit/>
+          </a:bodyPr>
+          <a:lstStyle/>
+          <a:p>
             <a:pPr algn="r">
-              <a:defRPr sz="1000">
+              <a:defRPr sz="900">
                 <a:solidFill>
                   <a:srgbClr val="6E8098"/>
                 </a:solidFill>
@@ -5289,7 +5646,7 @@
         <p:spPr>
           <a:xfrm>
             <a:off x="502920" y="6428232"/>
-            <a:ext cx="10972800" cy="292608"/>
+            <a:ext cx="8503920" cy="310896"/>
           </a:xfrm>
           <a:prstGeom prst="rect">
             <a:avLst/>
@@ -5302,8 +5659,75 @@
           </a:bodyPr>
           <a:lstStyle/>
           <a:p>
+            <a:pPr algn="l">
+              <a:spcAft>
+                <a:spcPts val="0"/>
+              </a:spcAft>
+            </a:pPr>
+            <a:r>
+              <a:rPr sz="850">
+                <a:solidFill>
+                  <a:srgbClr val="6E8098"/>
+                </a:solidFill>
+                <a:latin typeface="Aptos"/>
+              </a:rPr>
+              <a:t>Sources: </a:t>
+            </a:r>
+            <a:r>
+              <a:rPr sz="850">
+                <a:solidFill>
+                  <a:srgbClr val="6E8098"/>
+                </a:solidFill>
+                <a:latin typeface="Aptos"/>
+              </a:rPr>
+              <a:t>Project commits/artifacts (internal)</a:t>
+            </a:r>
+            <a:r>
+              <a:rPr sz="850">
+                <a:solidFill>
+                  <a:srgbClr val="8291A5"/>
+                </a:solidFill>
+                <a:latin typeface="Aptos"/>
+              </a:rPr>
+              <a:t> | </a:t>
+            </a:r>
+            <a:r>
+              <a:rPr sz="850" u="sng">
+                <a:solidFill>
+                  <a:srgbClr val="1A7DBC"/>
+                </a:solidFill>
+                <a:latin typeface="Aptos"/>
+                <a:hlinkClick r:id="rId2"/>
+              </a:rPr>
+              <a:t>OpenAI platform docs</a:t>
+            </a:r>
+          </a:p>
+        </p:txBody>
+      </p:sp>
+      <p:sp>
+        <p:nvSpPr>
+          <p:cNvPr id="11" name="TextBox 10"/>
+          <p:cNvSpPr txBox="1"/>
+          <p:nvPr/>
+        </p:nvSpPr>
+        <p:spPr>
+          <a:xfrm>
+            <a:off x="9189720" y="6428232"/>
+            <a:ext cx="2514600" cy="292608"/>
+          </a:xfrm>
+          <a:prstGeom prst="rect">
+            <a:avLst/>
+          </a:prstGeom>
+          <a:noFill/>
+        </p:spPr>
+        <p:txBody>
+          <a:bodyPr wrap="none">
+            <a:spAutoFit/>
+          </a:bodyPr>
+          <a:lstStyle/>
+          <a:p>
             <a:pPr algn="r">
-              <a:defRPr sz="1000">
+              <a:defRPr sz="900">
                 <a:solidFill>
                   <a:srgbClr val="6E8098"/>
                 </a:solidFill>
@@ -5540,8 +5964,8 @@
         </p:nvSpPr>
         <p:spPr>
           <a:xfrm>
-            <a:off x="749808" y="5577840"/>
-            <a:ext cx="10789920" cy="731520"/>
+            <a:off x="749808" y="5349240"/>
+            <a:ext cx="10789920" cy="594360"/>
           </a:xfrm>
           <a:prstGeom prst="rect">
             <a:avLst/>
@@ -5577,7 +6001,7 @@
         <p:spPr>
           <a:xfrm>
             <a:off x="502920" y="6428232"/>
-            <a:ext cx="10972800" cy="292608"/>
+            <a:ext cx="8503920" cy="310896"/>
           </a:xfrm>
           <a:prstGeom prst="rect">
             <a:avLst/>
@@ -5590,8 +6014,95 @@
           </a:bodyPr>
           <a:lstStyle/>
           <a:p>
+            <a:pPr algn="l">
+              <a:spcAft>
+                <a:spcPts val="0"/>
+              </a:spcAft>
+            </a:pPr>
+            <a:r>
+              <a:rPr sz="850">
+                <a:solidFill>
+                  <a:srgbClr val="6E8098"/>
+                </a:solidFill>
+                <a:latin typeface="Aptos"/>
+              </a:rPr>
+              <a:t>Sources: </a:t>
+            </a:r>
+            <a:r>
+              <a:rPr sz="850" u="sng">
+                <a:solidFill>
+                  <a:srgbClr val="1A7DBC"/>
+                </a:solidFill>
+                <a:latin typeface="Aptos"/>
+                <a:hlinkClick r:id="rId2"/>
+              </a:rPr>
+              <a:t>EMARKETER</a:t>
+            </a:r>
+            <a:r>
+              <a:rPr sz="850">
+                <a:solidFill>
+                  <a:srgbClr val="8291A5"/>
+                </a:solidFill>
+                <a:latin typeface="Aptos"/>
+              </a:rPr>
+              <a:t> | </a:t>
+            </a:r>
+            <a:r>
+              <a:rPr sz="850" u="sng">
+                <a:solidFill>
+                  <a:srgbClr val="1A7DBC"/>
+                </a:solidFill>
+                <a:latin typeface="Aptos"/>
+                <a:hlinkClick r:id="rId3"/>
+              </a:rPr>
+              <a:t>NIQ</a:t>
+            </a:r>
+            <a:r>
+              <a:rPr sz="850">
+                <a:solidFill>
+                  <a:srgbClr val="8291A5"/>
+                </a:solidFill>
+                <a:latin typeface="Aptos"/>
+              </a:rPr>
+              <a:t> | </a:t>
+            </a:r>
+            <a:r>
+              <a:rPr sz="850" u="sng">
+                <a:solidFill>
+                  <a:srgbClr val="1A7DBC"/>
+                </a:solidFill>
+                <a:latin typeface="Aptos"/>
+                <a:hlinkClick r:id="rId4"/>
+              </a:rPr>
+              <a:t>McKinsey</a:t>
+            </a:r>
+          </a:p>
+        </p:txBody>
+      </p:sp>
+      <p:sp>
+        <p:nvSpPr>
+          <p:cNvPr id="7" name="TextBox 6"/>
+          <p:cNvSpPr txBox="1"/>
+          <p:nvPr/>
+        </p:nvSpPr>
+        <p:spPr>
+          <a:xfrm>
+            <a:off x="9189720" y="6428232"/>
+            <a:ext cx="2514600" cy="292608"/>
+          </a:xfrm>
+          <a:prstGeom prst="rect">
+            <a:avLst/>
+          </a:prstGeom>
+          <a:noFill/>
+        </p:spPr>
+        <p:txBody>
+          <a:bodyPr wrap="none">
+            <a:spAutoFit/>
+          </a:bodyPr>
+          <a:lstStyle/>
+          <a:p>
             <a:pPr algn="r">
-              <a:defRPr sz="1000">
+              <a:defRPr sz="900">
                 <a:solidFill>
                   <a:srgbClr val="6E8098"/>
                 </a:solidFill>
@@ -5845,7 +6356,7 @@
         <p:spPr>
           <a:xfrm>
             <a:off x="502920" y="6428232"/>
-            <a:ext cx="10972800" cy="292608"/>
+            <a:ext cx="8503920" cy="310896"/>
           </a:xfrm>
           <a:prstGeom prst="rect">
             <a:avLst/>
@@ -5858,8 +6369,56 @@
           </a:bodyPr>
           <a:lstStyle/>
           <a:p>
+            <a:pPr algn="l">
+              <a:spcAft>
+                <a:spcPts val="0"/>
+              </a:spcAft>
+            </a:pPr>
+            <a:r>
+              <a:rPr sz="850">
+                <a:solidFill>
+                  <a:srgbClr val="6E8098"/>
+                </a:solidFill>
+                <a:latin typeface="Aptos"/>
+              </a:rPr>
+              <a:t>Sources: </a:t>
+            </a:r>
+            <a:r>
+              <a:rPr sz="850">
+                <a:solidFill>
+                  <a:srgbClr val="6E8098"/>
+                </a:solidFill>
+                <a:latin typeface="Aptos"/>
+              </a:rPr>
+              <a:t>MSIS 521 assignment/rubric (internal PDFs)</a:t>
+            </a:r>
+          </a:p>
+        </p:txBody>
+      </p:sp>
+      <p:sp>
+        <p:nvSpPr>
+          <p:cNvPr id="6" name="TextBox 5"/>
+          <p:cNvSpPr txBox="1"/>
+          <p:nvPr/>
+        </p:nvSpPr>
+        <p:spPr>
+          <a:xfrm>
+            <a:off x="9189720" y="6428232"/>
+            <a:ext cx="2514600" cy="292608"/>
+          </a:xfrm>
+          <a:prstGeom prst="rect">
+            <a:avLst/>
+          </a:prstGeom>
+          <a:noFill/>
+        </p:spPr>
+        <p:txBody>
+          <a:bodyPr wrap="none">
+            <a:spAutoFit/>
+          </a:bodyPr>
+          <a:lstStyle/>
+          <a:p>
             <a:pPr algn="r">
-              <a:defRPr sz="1000">
+              <a:defRPr sz="900">
                 <a:solidFill>
                   <a:srgbClr val="6E8098"/>
                 </a:solidFill>
@@ -6282,7 +6841,7 @@
         <p:spPr>
           <a:xfrm>
             <a:off x="502920" y="6428232"/>
-            <a:ext cx="10972800" cy="292608"/>
+            <a:ext cx="8503920" cy="310896"/>
           </a:xfrm>
           <a:prstGeom prst="rect">
             <a:avLst/>
@@ -6295,8 +6854,95 @@
           </a:bodyPr>
           <a:lstStyle/>
           <a:p>
+            <a:pPr algn="l">
+              <a:spcAft>
+                <a:spcPts val="0"/>
+              </a:spcAft>
+            </a:pPr>
+            <a:r>
+              <a:rPr sz="850">
+                <a:solidFill>
+                  <a:srgbClr val="6E8098"/>
+                </a:solidFill>
+                <a:latin typeface="Aptos"/>
+              </a:rPr>
+              <a:t>Sources: </a:t>
+            </a:r>
+            <a:r>
+              <a:rPr sz="850" u="sng">
+                <a:solidFill>
+                  <a:srgbClr val="1A7DBC"/>
+                </a:solidFill>
+                <a:latin typeface="Aptos"/>
+                <a:hlinkClick r:id="rId2"/>
+              </a:rPr>
+              <a:t>YouTube Content Manager</a:t>
+            </a:r>
+            <a:r>
+              <a:rPr sz="850">
+                <a:solidFill>
+                  <a:srgbClr val="8291A5"/>
+                </a:solidFill>
+                <a:latin typeface="Aptos"/>
+              </a:rPr>
+              <a:t> | </a:t>
+            </a:r>
+            <a:r>
+              <a:rPr sz="850" u="sng">
+                <a:solidFill>
+                  <a:srgbClr val="1A7DBC"/>
+                </a:solidFill>
+                <a:latin typeface="Aptos"/>
+                <a:hlinkClick r:id="rId3"/>
+              </a:rPr>
+              <a:t>YouTube MCN setup</a:t>
+            </a:r>
+            <a:r>
+              <a:rPr sz="850">
+                <a:solidFill>
+                  <a:srgbClr val="8291A5"/>
+                </a:solidFill>
+                <a:latin typeface="Aptos"/>
+              </a:rPr>
+              <a:t> | </a:t>
+            </a:r>
+            <a:r>
+              <a:rPr sz="850" u="sng">
+                <a:solidFill>
+                  <a:srgbClr val="1A7DBC"/>
+                </a:solidFill>
+                <a:latin typeface="Aptos"/>
+                <a:hlinkClick r:id="rId4"/>
+              </a:rPr>
+              <a:t>IAB Creator Economy</a:t>
+            </a:r>
+          </a:p>
+        </p:txBody>
+      </p:sp>
+      <p:sp>
+        <p:nvSpPr>
+          <p:cNvPr id="11" name="TextBox 10"/>
+          <p:cNvSpPr txBox="1"/>
+          <p:nvPr/>
+        </p:nvSpPr>
+        <p:spPr>
+          <a:xfrm>
+            <a:off x="9189720" y="6428232"/>
+            <a:ext cx="2514600" cy="292608"/>
+          </a:xfrm>
+          <a:prstGeom prst="rect">
+            <a:avLst/>
+          </a:prstGeom>
+          <a:noFill/>
+        </p:spPr>
+        <p:txBody>
+          <a:bodyPr wrap="none">
+            <a:spAutoFit/>
+          </a:bodyPr>
+          <a:lstStyle/>
+          <a:p>
             <a:pPr algn="r">
-              <a:defRPr sz="1000">
+              <a:defRPr sz="900">
                 <a:solidFill>
                   <a:srgbClr val="6E8098"/>
                 </a:solidFill>
@@ -6502,7 +7148,7 @@
         <p:spPr>
           <a:xfrm>
             <a:off x="502920" y="6428232"/>
-            <a:ext cx="10972800" cy="292608"/>
+            <a:ext cx="8503920" cy="310896"/>
           </a:xfrm>
           <a:prstGeom prst="rect">
             <a:avLst/>
@@ -6515,8 +7161,95 @@
           </a:bodyPr>
           <a:lstStyle/>
           <a:p>
+            <a:pPr algn="l">
+              <a:spcAft>
+                <a:spcPts val="0"/>
+              </a:spcAft>
+            </a:pPr>
+            <a:r>
+              <a:rPr sz="850">
+                <a:solidFill>
+                  <a:srgbClr val="6E8098"/>
+                </a:solidFill>
+                <a:latin typeface="Aptos"/>
+              </a:rPr>
+              <a:t>Sources: </a:t>
+            </a:r>
+            <a:r>
+              <a:rPr sz="850" u="sng">
+                <a:solidFill>
+                  <a:srgbClr val="1A7DBC"/>
+                </a:solidFill>
+                <a:latin typeface="Aptos"/>
+                <a:hlinkClick r:id="rId2"/>
+              </a:rPr>
+              <a:t>EMARKETER</a:t>
+            </a:r>
+            <a:r>
+              <a:rPr sz="850">
+                <a:solidFill>
+                  <a:srgbClr val="8291A5"/>
+                </a:solidFill>
+                <a:latin typeface="Aptos"/>
+              </a:rPr>
+              <a:t> | </a:t>
+            </a:r>
+            <a:r>
+              <a:rPr sz="850" u="sng">
+                <a:solidFill>
+                  <a:srgbClr val="1A7DBC"/>
+                </a:solidFill>
+                <a:latin typeface="Aptos"/>
+                <a:hlinkClick r:id="rId3"/>
+              </a:rPr>
+              <a:t>NIQ Beauty 2025</a:t>
+            </a:r>
+            <a:r>
+              <a:rPr sz="850">
+                <a:solidFill>
+                  <a:srgbClr val="8291A5"/>
+                </a:solidFill>
+                <a:latin typeface="Aptos"/>
+              </a:rPr>
+              <a:t> | </a:t>
+            </a:r>
+            <a:r>
+              <a:rPr sz="850" u="sng">
+                <a:solidFill>
+                  <a:srgbClr val="1A7DBC"/>
+                </a:solidFill>
+                <a:latin typeface="Aptos"/>
+                <a:hlinkClick r:id="rId4"/>
+              </a:rPr>
+              <a:t>McKinsey 2025</a:t>
+            </a:r>
+          </a:p>
+        </p:txBody>
+      </p:sp>
+      <p:sp>
+        <p:nvSpPr>
+          <p:cNvPr id="6" name="TextBox 5"/>
+          <p:cNvSpPr txBox="1"/>
+          <p:nvPr/>
+        </p:nvSpPr>
+        <p:spPr>
+          <a:xfrm>
+            <a:off x="9189720" y="6428232"/>
+            <a:ext cx="2514600" cy="292608"/>
+          </a:xfrm>
+          <a:prstGeom prst="rect">
+            <a:avLst/>
+          </a:prstGeom>
+          <a:noFill/>
+        </p:spPr>
+        <p:txBody>
+          <a:bodyPr wrap="none">
+            <a:spAutoFit/>
+          </a:bodyPr>
+          <a:lstStyle/>
+          <a:p>
             <a:pPr algn="r">
-              <a:defRPr sz="1000">
+              <a:defRPr sz="900">
                 <a:solidFill>
                   <a:srgbClr val="6E8098"/>
                 </a:solidFill>
@@ -6987,7 +7720,7 @@
         <p:spPr>
           <a:xfrm>
             <a:off x="502920" y="6428232"/>
-            <a:ext cx="10972800" cy="292608"/>
+            <a:ext cx="8503920" cy="310896"/>
           </a:xfrm>
           <a:prstGeom prst="rect">
             <a:avLst/>
@@ -7000,8 +7733,95 @@
           </a:bodyPr>
           <a:lstStyle/>
           <a:p>
+            <a:pPr algn="l">
+              <a:spcAft>
+                <a:spcPts val="0"/>
+              </a:spcAft>
+            </a:pPr>
+            <a:r>
+              <a:rPr sz="850">
+                <a:solidFill>
+                  <a:srgbClr val="6E8098"/>
+                </a:solidFill>
+                <a:latin typeface="Aptos"/>
+              </a:rPr>
+              <a:t>Sources: </a:t>
+            </a:r>
+            <a:r>
+              <a:rPr sz="850" u="sng">
+                <a:solidFill>
+                  <a:srgbClr val="1A7DBC"/>
+                </a:solidFill>
+                <a:latin typeface="Aptos"/>
+                <a:hlinkClick r:id="rId2"/>
+              </a:rPr>
+              <a:t>Fashionista BOJ</a:t>
+            </a:r>
+            <a:r>
+              <a:rPr sz="850">
+                <a:solidFill>
+                  <a:srgbClr val="8291A5"/>
+                </a:solidFill>
+                <a:latin typeface="Aptos"/>
+              </a:rPr>
+              <a:t> | </a:t>
+            </a:r>
+            <a:r>
+              <a:rPr sz="850" u="sng">
+                <a:solidFill>
+                  <a:srgbClr val="1A7DBC"/>
+                </a:solidFill>
+                <a:latin typeface="Aptos"/>
+                <a:hlinkClick r:id="rId3"/>
+              </a:rPr>
+              <a:t>BOJ Rice Wonderland</a:t>
+            </a:r>
+            <a:r>
+              <a:rPr sz="850">
+                <a:solidFill>
+                  <a:srgbClr val="8291A5"/>
+                </a:solidFill>
+                <a:latin typeface="Aptos"/>
+              </a:rPr>
+              <a:t> | </a:t>
+            </a:r>
+            <a:r>
+              <a:rPr sz="850" u="sng">
+                <a:solidFill>
+                  <a:srgbClr val="1A7DBC"/>
+                </a:solidFill>
+                <a:latin typeface="Aptos"/>
+                <a:hlinkClick r:id="rId4"/>
+              </a:rPr>
+              <a:t>FDA SIA</a:t>
+            </a:r>
+          </a:p>
+        </p:txBody>
+      </p:sp>
+      <p:sp>
+        <p:nvSpPr>
+          <p:cNvPr id="11" name="TextBox 10"/>
+          <p:cNvSpPr txBox="1"/>
+          <p:nvPr/>
+        </p:nvSpPr>
+        <p:spPr>
+          <a:xfrm>
+            <a:off x="9189720" y="6428232"/>
+            <a:ext cx="2514600" cy="292608"/>
+          </a:xfrm>
+          <a:prstGeom prst="rect">
+            <a:avLst/>
+          </a:prstGeom>
+          <a:noFill/>
+        </p:spPr>
+        <p:txBody>
+          <a:bodyPr wrap="none">
+            <a:spAutoFit/>
+          </a:bodyPr>
+          <a:lstStyle/>
+          <a:p>
             <a:pPr algn="r">
-              <a:defRPr sz="1000">
+              <a:defRPr sz="900">
                 <a:solidFill>
                   <a:srgbClr val="6E8098"/>
                 </a:solidFill>
@@ -7456,7 +8276,7 @@
         <p:spPr>
           <a:xfrm>
             <a:off x="502920" y="6428232"/>
-            <a:ext cx="10972800" cy="292608"/>
+            <a:ext cx="8503920" cy="310896"/>
           </a:xfrm>
           <a:prstGeom prst="rect">
             <a:avLst/>
@@ -7469,8 +8289,75 @@
           </a:bodyPr>
           <a:lstStyle/>
           <a:p>
+            <a:pPr algn="l">
+              <a:spcAft>
+                <a:spcPts val="0"/>
+              </a:spcAft>
+            </a:pPr>
+            <a:r>
+              <a:rPr sz="850">
+                <a:solidFill>
+                  <a:srgbClr val="6E8098"/>
+                </a:solidFill>
+                <a:latin typeface="Aptos"/>
+              </a:rPr>
+              <a:t>Sources: </a:t>
+            </a:r>
+            <a:r>
+              <a:rPr sz="850" u="sng">
+                <a:solidFill>
+                  <a:srgbClr val="1A7DBC"/>
+                </a:solidFill>
+                <a:latin typeface="Aptos"/>
+                <a:hlinkClick r:id="rId2"/>
+              </a:rPr>
+              <a:t>YouTube Data API</a:t>
+            </a:r>
+            <a:r>
+              <a:rPr sz="850">
+                <a:solidFill>
+                  <a:srgbClr val="8291A5"/>
+                </a:solidFill>
+                <a:latin typeface="Aptos"/>
+              </a:rPr>
+              <a:t> | </a:t>
+            </a:r>
+            <a:r>
+              <a:rPr sz="850">
+                <a:solidFill>
+                  <a:srgbClr val="6E8098"/>
+                </a:solidFill>
+                <a:latin typeface="Aptos"/>
+              </a:rPr>
+              <a:t>Project data files (internal)</a:t>
+            </a:r>
+          </a:p>
+        </p:txBody>
+      </p:sp>
+      <p:sp>
+        <p:nvSpPr>
+          <p:cNvPr id="11" name="TextBox 10"/>
+          <p:cNvSpPr txBox="1"/>
+          <p:nvPr/>
+        </p:nvSpPr>
+        <p:spPr>
+          <a:xfrm>
+            <a:off x="9189720" y="6428232"/>
+            <a:ext cx="2514600" cy="292608"/>
+          </a:xfrm>
+          <a:prstGeom prst="rect">
+            <a:avLst/>
+          </a:prstGeom>
+          <a:noFill/>
+        </p:spPr>
+        <p:txBody>
+          <a:bodyPr wrap="none">
+            <a:spAutoFit/>
+          </a:bodyPr>
+          <a:lstStyle/>
+          <a:p>
             <a:pPr algn="r">
-              <a:defRPr sz="1000">
+              <a:defRPr sz="900">
                 <a:solidFill>
                   <a:srgbClr val="6E8098"/>
                 </a:solidFill>
@@ -7781,7 +8668,7 @@
         <p:spPr>
           <a:xfrm>
             <a:off x="502920" y="6428232"/>
-            <a:ext cx="10972800" cy="292608"/>
+            <a:ext cx="8503920" cy="310896"/>
           </a:xfrm>
           <a:prstGeom prst="rect">
             <a:avLst/>
@@ -7794,8 +8681,74 @@
           </a:bodyPr>
           <a:lstStyle/>
           <a:p>
+            <a:pPr algn="l">
+              <a:spcAft>
+                <a:spcPts val="0"/>
+              </a:spcAft>
+            </a:pPr>
+            <a:r>
+              <a:rPr sz="850">
+                <a:solidFill>
+                  <a:srgbClr val="6E8098"/>
+                </a:solidFill>
+                <a:latin typeface="Aptos"/>
+              </a:rPr>
+              <a:t>Sources: </a:t>
+            </a:r>
+            <a:r>
+              <a:rPr sz="850">
+                <a:solidFill>
+                  <a:srgbClr val="6E8098"/>
+                </a:solidFill>
+                <a:latin typeface="Aptos"/>
+              </a:rPr>
+              <a:t>Preprocessing pipeline (internal)</a:t>
+            </a:r>
+            <a:r>
+              <a:rPr sz="850">
+                <a:solidFill>
+                  <a:srgbClr val="8291A5"/>
+                </a:solidFill>
+                <a:latin typeface="Aptos"/>
+              </a:rPr>
+              <a:t> | </a:t>
+            </a:r>
+            <a:r>
+              <a:rPr sz="850">
+                <a:solidFill>
+                  <a:srgbClr val="6E8098"/>
+                </a:solidFill>
+                <a:latin typeface="Aptos"/>
+              </a:rPr>
+              <a:t>EDA plots (internal)</a:t>
+            </a:r>
+          </a:p>
+        </p:txBody>
+      </p:sp>
+      <p:sp>
+        <p:nvSpPr>
+          <p:cNvPr id="9" name="TextBox 8"/>
+          <p:cNvSpPr txBox="1"/>
+          <p:nvPr/>
+        </p:nvSpPr>
+        <p:spPr>
+          <a:xfrm>
+            <a:off x="9189720" y="6428232"/>
+            <a:ext cx="2514600" cy="292608"/>
+          </a:xfrm>
+          <a:prstGeom prst="rect">
+            <a:avLst/>
+          </a:prstGeom>
+          <a:noFill/>
+        </p:spPr>
+        <p:txBody>
+          <a:bodyPr wrap="none">
+            <a:spAutoFit/>
+          </a:bodyPr>
+          <a:lstStyle/>
+          <a:p>
             <a:pPr algn="r">
-              <a:defRPr sz="1000">
+              <a:defRPr sz="900">
                 <a:solidFill>
                   <a:srgbClr val="6E8098"/>
                 </a:solidFill>
@@ -8033,7 +8986,7 @@
         <p:spPr>
           <a:xfrm>
             <a:off x="502920" y="6428232"/>
-            <a:ext cx="10972800" cy="292608"/>
+            <a:ext cx="8503920" cy="310896"/>
           </a:xfrm>
           <a:prstGeom prst="rect">
             <a:avLst/>
@@ -8046,8 +8999,95 @@
           </a:bodyPr>
           <a:lstStyle/>
           <a:p>
+            <a:pPr algn="l">
+              <a:spcAft>
+                <a:spcPts val="0"/>
+              </a:spcAft>
+            </a:pPr>
+            <a:r>
+              <a:rPr sz="850">
+                <a:solidFill>
+                  <a:srgbClr val="6E8098"/>
+                </a:solidFill>
+                <a:latin typeface="Aptos"/>
+              </a:rPr>
+              <a:t>Sources: </a:t>
+            </a:r>
+            <a:r>
+              <a:rPr sz="850" u="sng">
+                <a:solidFill>
+                  <a:srgbClr val="1A7DBC"/>
+                </a:solidFill>
+                <a:latin typeface="Aptos"/>
+                <a:hlinkClick r:id="rId2"/>
+              </a:rPr>
+              <a:t>GroupKFold</a:t>
+            </a:r>
+            <a:r>
+              <a:rPr sz="850">
+                <a:solidFill>
+                  <a:srgbClr val="8291A5"/>
+                </a:solidFill>
+                <a:latin typeface="Aptos"/>
+              </a:rPr>
+              <a:t> | </a:t>
+            </a:r>
+            <a:r>
+              <a:rPr sz="850" u="sng">
+                <a:solidFill>
+                  <a:srgbClr val="1A7DBC"/>
+                </a:solidFill>
+                <a:latin typeface="Aptos"/>
+                <a:hlinkClick r:id="rId3"/>
+              </a:rPr>
+              <a:t>LightGBM</a:t>
+            </a:r>
+            <a:r>
+              <a:rPr sz="850">
+                <a:solidFill>
+                  <a:srgbClr val="8291A5"/>
+                </a:solidFill>
+                <a:latin typeface="Aptos"/>
+              </a:rPr>
+              <a:t> | </a:t>
+            </a:r>
+            <a:r>
+              <a:rPr sz="850" u="sng">
+                <a:solidFill>
+                  <a:srgbClr val="1A7DBC"/>
+                </a:solidFill>
+                <a:latin typeface="Aptos"/>
+                <a:hlinkClick r:id="rId4"/>
+              </a:rPr>
+              <a:t>SHAP</a:t>
+            </a:r>
+          </a:p>
+        </p:txBody>
+      </p:sp>
+      <p:sp>
+        <p:nvSpPr>
+          <p:cNvPr id="6" name="TextBox 5"/>
+          <p:cNvSpPr txBox="1"/>
+          <p:nvPr/>
+        </p:nvSpPr>
+        <p:spPr>
+          <a:xfrm>
+            <a:off x="9189720" y="6428232"/>
+            <a:ext cx="2514600" cy="292608"/>
+          </a:xfrm>
+          <a:prstGeom prst="rect">
+            <a:avLst/>
+          </a:prstGeom>
+          <a:noFill/>
+        </p:spPr>
+        <p:txBody>
+          <a:bodyPr wrap="none">
+            <a:spAutoFit/>
+          </a:bodyPr>
+          <a:lstStyle/>
+          <a:p>
             <a:pPr algn="r">
-              <a:defRPr sz="1000">
+              <a:defRPr sz="900">
                 <a:solidFill>
                   <a:srgbClr val="6E8098"/>
                 </a:solidFill>
@@ -8502,7 +9542,7 @@
         <p:spPr>
           <a:xfrm>
             <a:off x="502920" y="6428232"/>
-            <a:ext cx="10972800" cy="292608"/>
+            <a:ext cx="8503920" cy="310896"/>
           </a:xfrm>
           <a:prstGeom prst="rect">
             <a:avLst/>
@@ -8515,8 +9555,95 @@
           </a:bodyPr>
           <a:lstStyle/>
           <a:p>
+            <a:pPr algn="l">
+              <a:spcAft>
+                <a:spcPts val="0"/>
+              </a:spcAft>
+            </a:pPr>
+            <a:r>
+              <a:rPr sz="850">
+                <a:solidFill>
+                  <a:srgbClr val="6E8098"/>
+                </a:solidFill>
+                <a:latin typeface="Aptos"/>
+              </a:rPr>
+              <a:t>Sources: </a:t>
+            </a:r>
+            <a:r>
+              <a:rPr sz="850" u="sng">
+                <a:solidFill>
+                  <a:srgbClr val="1A7DBC"/>
+                </a:solidFill>
+                <a:latin typeface="Aptos"/>
+                <a:hlinkClick r:id="rId2"/>
+              </a:rPr>
+              <a:t>FTC Influencers</a:t>
+            </a:r>
+            <a:r>
+              <a:rPr sz="850">
+                <a:solidFill>
+                  <a:srgbClr val="8291A5"/>
+                </a:solidFill>
+                <a:latin typeface="Aptos"/>
+              </a:rPr>
+              <a:t> | </a:t>
+            </a:r>
+            <a:r>
+              <a:rPr sz="850" u="sng">
+                <a:solidFill>
+                  <a:srgbClr val="1A7DBC"/>
+                </a:solidFill>
+                <a:latin typeface="Aptos"/>
+                <a:hlinkClick r:id="rId3"/>
+              </a:rPr>
+              <a:t>FTC Endorsement Guides</a:t>
+            </a:r>
+            <a:r>
+              <a:rPr sz="850">
+                <a:solidFill>
+                  <a:srgbClr val="8291A5"/>
+                </a:solidFill>
+                <a:latin typeface="Aptos"/>
+              </a:rPr>
+              <a:t> | </a:t>
+            </a:r>
+            <a:r>
+              <a:rPr sz="850" u="sng">
+                <a:solidFill>
+                  <a:srgbClr val="1A7DBC"/>
+                </a:solidFill>
+                <a:latin typeface="Aptos"/>
+                <a:hlinkClick r:id="rId4"/>
+              </a:rPr>
+              <a:t>YouTube MCN reference</a:t>
+            </a:r>
+          </a:p>
+        </p:txBody>
+      </p:sp>
+      <p:sp>
+        <p:nvSpPr>
+          <p:cNvPr id="11" name="TextBox 10"/>
+          <p:cNvSpPr txBox="1"/>
+          <p:nvPr/>
+        </p:nvSpPr>
+        <p:spPr>
+          <a:xfrm>
+            <a:off x="9189720" y="6428232"/>
+            <a:ext cx="2514600" cy="292608"/>
+          </a:xfrm>
+          <a:prstGeom prst="rect">
+            <a:avLst/>
+          </a:prstGeom>
+          <a:noFill/>
+        </p:spPr>
+        <p:txBody>
+          <a:bodyPr wrap="none">
+            <a:spAutoFit/>
+          </a:bodyPr>
+          <a:lstStyle/>
+          <a:p>
             <a:pPr algn="r">
-              <a:defRPr sz="1000">
+              <a:defRPr sz="900">
                 <a:solidFill>
                   <a:srgbClr val="6E8098"/>
                 </a:solidFill>

</xml_diff>